<commit_message>
dh cert and defense presentation
</commit_message>
<xml_diff>
--- a/draft/pres.pptx
+++ b/draft/pres.pptx
@@ -16,6 +16,13 @@
     <p:sldId id="264" r:id="rId11"/>
     <p:sldId id="265" r:id="rId12"/>
     <p:sldId id="266" r:id="rId13"/>
+    <p:sldId id="267" r:id="rId14"/>
+    <p:sldId id="268" r:id="rId15"/>
+    <p:sldId id="269" r:id="rId16"/>
+    <p:sldId id="270" r:id="rId17"/>
+    <p:sldId id="271" r:id="rId18"/>
+    <p:sldId id="272" r:id="rId19"/>
+    <p:sldId id="273" r:id="rId20"/>
   </p:sldIdLst>
   <p:sldSz cx="10080625" cy="5670550"/>
   <p:notesSz cx="7772400" cy="10058400"/>
@@ -73,7 +80,7 @@
         <p:txBody>
           <a:bodyPr/>
           <a:p>
-            <a:fld id="{9EBA0427-20A7-4143-ABF9-8F2CE9D3885B}" type="slidenum">
+            <a:fld id="{69D36E63-F7A2-4925-ABF9-CFE8FE6487EE}" type="slidenum">
               <a:t>&lt;#&gt;</a:t>
             </a:fld>
           </a:p>
@@ -243,7 +250,7 @@
         <p:txBody>
           <a:bodyPr/>
           <a:p>
-            <a:fld id="{ED2D65D7-AF75-434B-A80F-2F0862D2D5BC}" type="slidenum">
+            <a:fld id="{468DC1BE-1CC4-4AE1-A853-52C0AD344CEE}" type="slidenum">
               <a:t>&lt;#&gt;</a:t>
             </a:fld>
           </a:p>
@@ -410,7 +417,7 @@
         <p:txBody>
           <a:bodyPr/>
           <a:p>
-            <a:fld id="{AF8AF8BB-A26D-4A71-9C23-953B527466B5}" type="slidenum">
+            <a:fld id="{6D089646-C2C7-46EB-AA49-C0F082EC8399}" type="slidenum">
               <a:t>&lt;#&gt;</a:t>
             </a:fld>
           </a:p>
@@ -941,7 +948,7 @@
             <a:pPr indent="0" algn="r">
               <a:buNone/>
             </a:pPr>
-            <a:fld id="{70BAC81F-5764-445C-89EC-B086C4976D53}" type="slidenum">
+            <a:fld id="{51864B35-CCE8-4110-A854-5399CDBFEE05}" type="slidenum">
               <a:rPr b="0" lang="en-US" sz="1400" strike="noStrike" u="none">
                 <a:solidFill>
                   <a:srgbClr val="000000"/>
@@ -1023,7 +1030,7 @@
               <a:buNone/>
             </a:pPr>
             <a:r>
-              <a:rPr b="0" lang="en-US" sz="3200" strike="noStrike" u="none">
+              <a:rPr b="0" i="1" lang="en-US" sz="3200" strike="noStrike" u="none">
                 <a:solidFill>
                   <a:srgbClr val="000000"/>
                 </a:solidFill>
@@ -1037,7 +1044,7 @@
               <a:rPr sz="3200"/>
             </a:br>
             <a:r>
-              <a:rPr b="0" lang="en-US" sz="3200" strike="noStrike" u="none">
+              <a:rPr b="0" i="1" lang="en-US" sz="3200" strike="noStrike" u="none">
                 <a:solidFill>
                   <a:srgbClr val="000000"/>
                 </a:solidFill>
@@ -1102,6 +1109,17 @@
             <a:pPr indent="0" algn="ctr">
               <a:buNone/>
             </a:pPr>
+            <a:r>
+              <a:rPr b="0" lang="en-US" sz="2000" strike="noStrike" u="none">
+                <a:solidFill>
+                  <a:srgbClr val="000000"/>
+                </a:solidFill>
+                <a:effectLst/>
+                <a:uFillTx/>
+                <a:latin typeface="Arial"/>
+              </a:rPr>
+              <a:t>by</a:t>
+            </a:r>
             <a:endParaRPr b="0" lang="en-US" sz="2000" strike="noStrike" u="none">
               <a:solidFill>
                 <a:srgbClr val="000000"/>
@@ -1115,17 +1133,6 @@
             <a:pPr indent="0" algn="ctr">
               <a:buNone/>
             </a:pPr>
-            <a:r>
-              <a:rPr b="0" lang="en-US" sz="2000" strike="noStrike" u="none">
-                <a:solidFill>
-                  <a:srgbClr val="000000"/>
-                </a:solidFill>
-                <a:effectLst/>
-                <a:uFillTx/>
-                <a:latin typeface="Arial"/>
-              </a:rPr>
-              <a:t>by</a:t>
-            </a:r>
             <a:endParaRPr b="0" lang="en-US" sz="2000" strike="noStrike" u="none">
               <a:solidFill>
                 <a:srgbClr val="000000"/>
@@ -1139,22 +1146,6 @@
             <a:pPr indent="0" algn="ctr">
               <a:buNone/>
             </a:pPr>
-            <a:endParaRPr b="0" lang="en-US" sz="2000" strike="noStrike" u="none">
-              <a:solidFill>
-                <a:srgbClr val="000000"/>
-              </a:solidFill>
-              <a:effectLst/>
-              <a:uFillTx/>
-              <a:latin typeface="Arial"/>
-            </a:endParaRPr>
-          </a:p>
-          <a:p>
-            <a:pPr indent="0" algn="ctr">
-              <a:buNone/>
-            </a:pPr>
-            <a:br>
-              <a:rPr sz="2000"/>
-            </a:br>
             <a:r>
               <a:rPr b="0" lang="en-US" sz="2000" strike="noStrike" u="none">
                 <a:solidFill>
@@ -1282,7 +1273,7 @@
                 <a:uFillTx/>
                 <a:latin typeface="Arial"/>
               </a:rPr>
-              <a:t>April 3, 2025</a:t>
+              <a:t>April 4, 2025</a:t>
             </a:r>
             <a:endParaRPr b="0" lang="en-US" sz="2000" strike="noStrike" u="none">
               <a:solidFill>
@@ -1327,7 +1318,7 @@
       </p:grpSpPr>
       <p:sp>
         <p:nvSpPr>
-          <p:cNvPr id="24" name="PlaceHolder 1"/>
+          <p:cNvPr id="25" name="PlaceHolder 1"/>
           <p:cNvSpPr>
             <a:spLocks noGrp="1"/>
           </p:cNvSpPr>
@@ -1337,7 +1328,7 @@
         </p:nvSpPr>
         <p:spPr>
           <a:xfrm>
-            <a:off x="504000" y="225720"/>
+            <a:off x="504000" y="226080"/>
             <a:ext cx="9071640" cy="946440"/>
           </a:xfrm>
           <a:prstGeom prst="rect">
@@ -1357,17 +1348,17 @@
               <a:buNone/>
             </a:pPr>
             <a:r>
-              <a:rPr b="0" lang="en-US" sz="3600" strike="noStrike" u="none">
-                <a:solidFill>
-                  <a:srgbClr val="000000"/>
-                </a:solidFill>
-                <a:effectLst/>
-                <a:uFillTx/>
-                <a:latin typeface="Arial"/>
-              </a:rPr>
-              <a:t>Active Engagement with Christian Heritage</a:t>
-            </a:r>
-            <a:endParaRPr b="0" lang="en-US" sz="3600" strike="noStrike" u="none">
+              <a:rPr b="0" lang="en-US" sz="4400" strike="noStrike" u="none">
+                <a:solidFill>
+                  <a:srgbClr val="000000"/>
+                </a:solidFill>
+                <a:effectLst/>
+                <a:uFillTx/>
+                <a:latin typeface="Arial"/>
+              </a:rPr>
+              <a:t>Scholarly Conception of MG</a:t>
+            </a:r>
+            <a:endParaRPr b="0" lang="en-US" sz="4400" strike="noStrike" u="none">
               <a:solidFill>
                 <a:srgbClr val="000000"/>
               </a:solidFill>
@@ -1380,7 +1371,7 @@
       </p:sp>
       <p:sp>
         <p:nvSpPr>
-          <p:cNvPr id="25" name="PlaceHolder 2"/>
+          <p:cNvPr id="26" name="PlaceHolder 2"/>
           <p:cNvSpPr>
             <a:spLocks noGrp="1"/>
           </p:cNvSpPr>
@@ -1406,12 +1397,124 @@
             <a:normAutofit/>
           </a:bodyPr>
           <a:p>
-            <a:pPr indent="0">
+            <a:pPr marL="432000" indent="-324000">
               <a:spcBef>
                 <a:spcPts val="1417"/>
               </a:spcBef>
-              <a:buNone/>
-            </a:pPr>
+              <a:buClr>
+                <a:srgbClr val="000000"/>
+              </a:buClr>
+              <a:buSzPct val="45000"/>
+              <a:buFont typeface="Wingdings" charset="2"/>
+              <a:buChar char=""/>
+            </a:pPr>
+            <a:r>
+              <a:rPr b="0" lang="en-US" sz="3200" strike="noStrike" u="none">
+                <a:solidFill>
+                  <a:srgbClr val="000000"/>
+                </a:solidFill>
+                <a:effectLst/>
+                <a:uFillTx/>
+                <a:latin typeface="Arial"/>
+              </a:rPr>
+              <a:t>Founder of Socialist Realism</a:t>
+            </a:r>
+            <a:endParaRPr b="0" lang="en-US" sz="3200" strike="noStrike" u="none">
+              <a:solidFill>
+                <a:srgbClr val="000000"/>
+              </a:solidFill>
+              <a:effectLst/>
+              <a:uFillTx/>
+              <a:latin typeface="Arial"/>
+            </a:endParaRPr>
+          </a:p>
+          <a:p>
+            <a:pPr marL="432000" indent="-324000">
+              <a:spcBef>
+                <a:spcPts val="1417"/>
+              </a:spcBef>
+              <a:buClr>
+                <a:srgbClr val="000000"/>
+              </a:buClr>
+              <a:buSzPct val="45000"/>
+              <a:buFont typeface="Wingdings" charset="2"/>
+              <a:buChar char=""/>
+            </a:pPr>
+            <a:r>
+              <a:rPr b="0" lang="en-US" sz="3200" strike="noStrike" u="none">
+                <a:solidFill>
+                  <a:srgbClr val="000000"/>
+                </a:solidFill>
+                <a:effectLst/>
+                <a:uFillTx/>
+                <a:latin typeface="Arial"/>
+              </a:rPr>
+              <a:t>Soviet scholars: viewed MG through eyes of Lenin/Party</a:t>
+            </a:r>
+            <a:endParaRPr b="0" lang="en-US" sz="3200" strike="noStrike" u="none">
+              <a:solidFill>
+                <a:srgbClr val="000000"/>
+              </a:solidFill>
+              <a:effectLst/>
+              <a:uFillTx/>
+              <a:latin typeface="Arial"/>
+            </a:endParaRPr>
+          </a:p>
+          <a:p>
+            <a:pPr marL="432000" indent="-324000">
+              <a:spcBef>
+                <a:spcPts val="1417"/>
+              </a:spcBef>
+              <a:buClr>
+                <a:srgbClr val="000000"/>
+              </a:buClr>
+              <a:buSzPct val="45000"/>
+              <a:buFont typeface="Wingdings" charset="2"/>
+              <a:buChar char=""/>
+            </a:pPr>
+            <a:r>
+              <a:rPr b="0" lang="en-US" sz="3200" strike="noStrike" u="none">
+                <a:solidFill>
+                  <a:srgbClr val="000000"/>
+                </a:solidFill>
+                <a:effectLst/>
+                <a:uFillTx/>
+                <a:latin typeface="Arial"/>
+              </a:rPr>
+              <a:t>Post-Soviet: waning influence through a diversity of perspectives</a:t>
+            </a:r>
+            <a:endParaRPr b="0" lang="en-US" sz="3200" strike="noStrike" u="none">
+              <a:solidFill>
+                <a:srgbClr val="000000"/>
+              </a:solidFill>
+              <a:effectLst/>
+              <a:uFillTx/>
+              <a:latin typeface="Arial"/>
+            </a:endParaRPr>
+          </a:p>
+          <a:p>
+            <a:pPr marL="432000" indent="-324000">
+              <a:spcBef>
+                <a:spcPts val="1417"/>
+              </a:spcBef>
+              <a:buClr>
+                <a:srgbClr val="000000"/>
+              </a:buClr>
+              <a:buSzPct val="45000"/>
+              <a:buFont typeface="Wingdings" charset="2"/>
+              <a:buChar char=""/>
+            </a:pPr>
+            <a:r>
+              <a:rPr b="0" lang="en-US" sz="3200" strike="noStrike" u="none">
+                <a:solidFill>
+                  <a:srgbClr val="000000"/>
+                </a:solidFill>
+                <a:effectLst/>
+                <a:uFillTx/>
+                <a:latin typeface="Arial"/>
+              </a:rPr>
+              <a:t>Current: out of fashion, mostly settled questions</a:t>
+            </a:r>
             <a:endParaRPr b="0" lang="en-US" sz="3200" strike="noStrike" u="none">
               <a:solidFill>
                 <a:srgbClr val="000000"/>
@@ -1455,7 +1558,7 @@
       </p:grpSpPr>
       <p:sp>
         <p:nvSpPr>
-          <p:cNvPr id="26" name="PlaceHolder 1"/>
+          <p:cNvPr id="27" name="PlaceHolder 1"/>
           <p:cNvSpPr>
             <a:spLocks noGrp="1"/>
           </p:cNvSpPr>
@@ -1491,8 +1594,1129 @@
                 <a:uFillTx/>
                 <a:latin typeface="Arial"/>
               </a:rPr>
+              <a:t>The Results</a:t>
+            </a:r>
+            <a:endParaRPr b="0" lang="en-US" sz="3200" strike="noStrike" u="none">
+              <a:solidFill>
+                <a:srgbClr val="000000"/>
+              </a:solidFill>
+              <a:effectLst/>
+              <a:uFillTx/>
+              <a:latin typeface="Arial"/>
+            </a:endParaRPr>
+          </a:p>
+        </p:txBody>
+      </p:sp>
+    </p:spTree>
+  </p:cSld>
+  <mc:AlternateContent>
+    <mc:Choice Requires="p14">
+      <p:transition spd="slow" p14:dur="2000"/>
+    </mc:Choice>
+    <mc:Fallback>
+      <p:transition spd="slow"/>
+    </mc:Fallback>
+  </mc:AlternateContent>
+</p:sld>
+</file>
+
+<file path=ppt/slides/slide12.xml><?xml version="1.0" encoding="utf-8"?>
+<p:sld xmlns:a="http://schemas.openxmlformats.org/drawingml/2006/main" xmlns:p="http://schemas.openxmlformats.org/presentationml/2006/main" xmlns:r="http://schemas.openxmlformats.org/officeDocument/2006/relationships" xmlns:p14="http://schemas.microsoft.com/office/powerpoint/2010/main" xmlns:p15="http://schemas.microsoft.com/office/powerpoint/2012/main" xmlns:mc="http://schemas.openxmlformats.org/markup-compatibility/2006">
+  <p:cSld>
+    <p:spTree>
+      <p:nvGrpSpPr>
+        <p:cNvPr id="1" name=""/>
+        <p:cNvGrpSpPr/>
+        <p:nvPr/>
+      </p:nvGrpSpPr>
+      <p:grpSpPr>
+        <a:xfrm>
+          <a:off x="0" y="0"/>
+          <a:ext cx="0" cy="0"/>
+          <a:chOff x="0" y="0"/>
+          <a:chExt cx="0" cy="0"/>
+        </a:xfrm>
+      </p:grpSpPr>
+      <p:sp>
+        <p:nvSpPr>
+          <p:cNvPr id="28" name="PlaceHolder 1"/>
+          <p:cNvSpPr>
+            <a:spLocks noGrp="1"/>
+          </p:cNvSpPr>
+          <p:nvPr>
+            <p:ph type="title"/>
+          </p:nvPr>
+        </p:nvSpPr>
+        <p:spPr>
+          <a:xfrm>
+            <a:off x="504000" y="225720"/>
+            <a:ext cx="9071640" cy="946440"/>
+          </a:xfrm>
+          <a:prstGeom prst="rect">
+            <a:avLst/>
+          </a:prstGeom>
+          <a:noFill/>
+          <a:ln w="0">
+            <a:noFill/>
+          </a:ln>
+        </p:spPr>
+        <p:txBody>
+          <a:bodyPr lIns="0" rIns="0" tIns="0" bIns="0" anchor="ctr">
+            <a:spAutoFit/>
+          </a:bodyPr>
+          <a:p>
+            <a:pPr indent="0" algn="ctr">
+              <a:buNone/>
+            </a:pPr>
+            <a:r>
+              <a:rPr b="0" lang="en-US" sz="3600" strike="noStrike" u="none">
+                <a:solidFill>
+                  <a:srgbClr val="000000"/>
+                </a:solidFill>
+                <a:effectLst/>
+                <a:uFillTx/>
+                <a:latin typeface="Arial"/>
+              </a:rPr>
+              <a:t>Active Engagement with Christian Heritage</a:t>
+            </a:r>
+            <a:endParaRPr b="0" lang="en-US" sz="3600" strike="noStrike" u="none">
+              <a:solidFill>
+                <a:srgbClr val="000000"/>
+              </a:solidFill>
+              <a:effectLst/>
+              <a:uFillTx/>
+              <a:latin typeface="Arial"/>
+            </a:endParaRPr>
+          </a:p>
+        </p:txBody>
+      </p:sp>
+      <p:sp>
+        <p:nvSpPr>
+          <p:cNvPr id="29" name="PlaceHolder 2"/>
+          <p:cNvSpPr>
+            <a:spLocks noGrp="1"/>
+          </p:cNvSpPr>
+          <p:nvPr>
+            <p:ph/>
+          </p:nvPr>
+        </p:nvSpPr>
+        <p:spPr>
+          <a:xfrm>
+            <a:off x="504000" y="1326600"/>
+            <a:ext cx="9071640" cy="3288240"/>
+          </a:xfrm>
+          <a:prstGeom prst="rect">
+            <a:avLst/>
+          </a:prstGeom>
+          <a:noFill/>
+          <a:ln w="0">
+            <a:noFill/>
+          </a:ln>
+        </p:spPr>
+        <p:txBody>
+          <a:bodyPr lIns="0" rIns="0" tIns="0" bIns="0" anchor="t">
+            <a:normAutofit/>
+          </a:bodyPr>
+          <a:p>
+            <a:pPr marL="432000" indent="-324000">
+              <a:spcBef>
+                <a:spcPts val="1417"/>
+              </a:spcBef>
+              <a:buClr>
+                <a:srgbClr val="000000"/>
+              </a:buClr>
+              <a:buSzPct val="45000"/>
+              <a:buFont typeface="Wingdings" charset="2"/>
+              <a:buChar char=""/>
+            </a:pPr>
+            <a:r>
+              <a:rPr b="0" lang="en-US" sz="3200" strike="noStrike" u="none">
+                <a:solidFill>
+                  <a:srgbClr val="000000"/>
+                </a:solidFill>
+                <a:effectLst/>
+                <a:uFillTx/>
+                <a:latin typeface="Arial"/>
+              </a:rPr>
+              <a:t>In actuality, much to be questioned and answered</a:t>
+            </a:r>
+            <a:endParaRPr b="0" lang="en-US" sz="3200" strike="noStrike" u="none">
+              <a:solidFill>
+                <a:srgbClr val="000000"/>
+              </a:solidFill>
+              <a:effectLst/>
+              <a:uFillTx/>
+              <a:latin typeface="Arial"/>
+            </a:endParaRPr>
+          </a:p>
+          <a:p>
+            <a:pPr marL="432000" indent="-324000">
+              <a:spcBef>
+                <a:spcPts val="1417"/>
+              </a:spcBef>
+              <a:buClr>
+                <a:srgbClr val="000000"/>
+              </a:buClr>
+              <a:buSzPct val="45000"/>
+              <a:buFont typeface="Wingdings" charset="2"/>
+              <a:buChar char=""/>
+            </a:pPr>
+            <a:r>
+              <a:rPr b="0" lang="en-US" sz="3200" strike="noStrike" u="none">
+                <a:solidFill>
+                  <a:srgbClr val="000000"/>
+                </a:solidFill>
+                <a:effectLst/>
+                <a:uFillTx/>
+                <a:latin typeface="Arial"/>
+              </a:rPr>
+              <a:t>Youth spent with grandmother, grandfather, and God</a:t>
+            </a:r>
+            <a:endParaRPr b="0" lang="en-US" sz="3200" strike="noStrike" u="none">
+              <a:solidFill>
+                <a:srgbClr val="000000"/>
+              </a:solidFill>
+              <a:effectLst/>
+              <a:uFillTx/>
+              <a:latin typeface="Arial"/>
+            </a:endParaRPr>
+          </a:p>
+          <a:p>
+            <a:pPr marL="432000" indent="-324000">
+              <a:spcBef>
+                <a:spcPts val="1417"/>
+              </a:spcBef>
+              <a:buClr>
+                <a:srgbClr val="000000"/>
+              </a:buClr>
+              <a:buSzPct val="45000"/>
+              <a:buFont typeface="Wingdings" charset="2"/>
+              <a:buChar char=""/>
+            </a:pPr>
+            <a:r>
+              <a:rPr b="0" lang="en-US" sz="3200" strike="noStrike" u="none">
+                <a:solidFill>
+                  <a:srgbClr val="000000"/>
+                </a:solidFill>
+                <a:effectLst/>
+                <a:uFillTx/>
+                <a:latin typeface="Arial"/>
+              </a:rPr>
+              <a:t>Early career experimenting with syncretic model without much success</a:t>
+            </a:r>
+            <a:endParaRPr b="0" lang="en-US" sz="3200" strike="noStrike" u="none">
+              <a:solidFill>
+                <a:srgbClr val="000000"/>
+              </a:solidFill>
+              <a:effectLst/>
+              <a:uFillTx/>
+              <a:latin typeface="Arial"/>
+            </a:endParaRPr>
+          </a:p>
+        </p:txBody>
+      </p:sp>
+    </p:spTree>
+  </p:cSld>
+  <mc:AlternateContent>
+    <mc:Choice Requires="p14">
+      <p:transition spd="slow" p14:dur="2000"/>
+    </mc:Choice>
+    <mc:Fallback>
+      <p:transition spd="slow"/>
+    </mc:Fallback>
+  </mc:AlternateContent>
+</p:sld>
+</file>
+
+<file path=ppt/slides/slide13.xml><?xml version="1.0" encoding="utf-8"?>
+<p:sld xmlns:a="http://schemas.openxmlformats.org/drawingml/2006/main" xmlns:p="http://schemas.openxmlformats.org/presentationml/2006/main" xmlns:r="http://schemas.openxmlformats.org/officeDocument/2006/relationships" xmlns:p14="http://schemas.microsoft.com/office/powerpoint/2010/main" xmlns:p15="http://schemas.microsoft.com/office/powerpoint/2012/main" xmlns:mc="http://schemas.openxmlformats.org/markup-compatibility/2006">
+  <p:cSld>
+    <p:spTree>
+      <p:nvGrpSpPr>
+        <p:cNvPr id="1" name=""/>
+        <p:cNvGrpSpPr/>
+        <p:nvPr/>
+      </p:nvGrpSpPr>
+      <p:grpSpPr>
+        <a:xfrm>
+          <a:off x="0" y="0"/>
+          <a:ext cx="0" cy="0"/>
+          <a:chOff x="0" y="0"/>
+          <a:chExt cx="0" cy="0"/>
+        </a:xfrm>
+      </p:grpSpPr>
+      <p:sp>
+        <p:nvSpPr>
+          <p:cNvPr id="30" name="PlaceHolder 1"/>
+          <p:cNvSpPr>
+            <a:spLocks noGrp="1"/>
+          </p:cNvSpPr>
+          <p:nvPr>
+            <p:ph type="title"/>
+          </p:nvPr>
+        </p:nvSpPr>
+        <p:spPr>
+          <a:xfrm>
+            <a:off x="504000" y="226080"/>
+            <a:ext cx="9071640" cy="946440"/>
+          </a:xfrm>
+          <a:prstGeom prst="rect">
+            <a:avLst/>
+          </a:prstGeom>
+          <a:noFill/>
+          <a:ln w="0">
+            <a:noFill/>
+          </a:ln>
+        </p:spPr>
+        <p:txBody>
+          <a:bodyPr lIns="0" rIns="0" tIns="0" bIns="0" anchor="ctr">
+            <a:spAutoFit/>
+          </a:bodyPr>
+          <a:p>
+            <a:pPr indent="0" algn="ctr">
+              <a:buNone/>
+            </a:pPr>
+            <a:r>
+              <a:rPr b="0" lang="en-US" sz="4400" strike="noStrike" u="none">
+                <a:solidFill>
+                  <a:srgbClr val="000000"/>
+                </a:solidFill>
+                <a:effectLst/>
+                <a:uFillTx/>
+                <a:latin typeface="Arial"/>
+              </a:rPr>
+              <a:t>1892-1900</a:t>
+            </a:r>
+            <a:endParaRPr b="0" lang="en-US" sz="4400" strike="noStrike" u="none">
+              <a:solidFill>
+                <a:srgbClr val="000000"/>
+              </a:solidFill>
+              <a:effectLst/>
+              <a:uFillTx/>
+              <a:latin typeface="Arial"/>
+            </a:endParaRPr>
+          </a:p>
+        </p:txBody>
+      </p:sp>
+      <p:sp>
+        <p:nvSpPr>
+          <p:cNvPr id="31" name="PlaceHolder 2"/>
+          <p:cNvSpPr>
+            <a:spLocks noGrp="1"/>
+          </p:cNvSpPr>
+          <p:nvPr>
+            <p:ph/>
+          </p:nvPr>
+        </p:nvSpPr>
+        <p:spPr>
+          <a:xfrm>
+            <a:off x="504000" y="1326600"/>
+            <a:ext cx="9071640" cy="3288240"/>
+          </a:xfrm>
+          <a:prstGeom prst="rect">
+            <a:avLst/>
+          </a:prstGeom>
+          <a:noFill/>
+          <a:ln w="0">
+            <a:noFill/>
+          </a:ln>
+        </p:spPr>
+        <p:txBody>
+          <a:bodyPr lIns="0" rIns="0" tIns="0" bIns="0" anchor="t">
+            <a:normAutofit/>
+          </a:bodyPr>
+          <a:p>
+            <a:pPr indent="0">
+              <a:spcBef>
+                <a:spcPts val="1417"/>
+              </a:spcBef>
+              <a:buNone/>
+            </a:pPr>
+            <a:endParaRPr b="0" lang="en-US" sz="3200" strike="noStrike" u="none">
+              <a:solidFill>
+                <a:srgbClr val="000000"/>
+              </a:solidFill>
+              <a:effectLst/>
+              <a:uFillTx/>
+              <a:latin typeface="Arial"/>
+            </a:endParaRPr>
+          </a:p>
+        </p:txBody>
+      </p:sp>
+    </p:spTree>
+  </p:cSld>
+  <mc:AlternateContent>
+    <mc:Choice Requires="p14">
+      <p:transition spd="slow" p14:dur="2000"/>
+    </mc:Choice>
+    <mc:Fallback>
+      <p:transition spd="slow"/>
+    </mc:Fallback>
+  </mc:AlternateContent>
+</p:sld>
+</file>
+
+<file path=ppt/slides/slide14.xml><?xml version="1.0" encoding="utf-8"?>
+<p:sld xmlns:a="http://schemas.openxmlformats.org/drawingml/2006/main" xmlns:p="http://schemas.openxmlformats.org/presentationml/2006/main" xmlns:r="http://schemas.openxmlformats.org/officeDocument/2006/relationships" xmlns:p14="http://schemas.microsoft.com/office/powerpoint/2010/main" xmlns:p15="http://schemas.microsoft.com/office/powerpoint/2012/main" xmlns:mc="http://schemas.openxmlformats.org/markup-compatibility/2006">
+  <p:cSld>
+    <p:spTree>
+      <p:nvGrpSpPr>
+        <p:cNvPr id="1" name=""/>
+        <p:cNvGrpSpPr/>
+        <p:nvPr/>
+      </p:nvGrpSpPr>
+      <p:grpSpPr>
+        <a:xfrm>
+          <a:off x="0" y="0"/>
+          <a:ext cx="0" cy="0"/>
+          <a:chOff x="0" y="0"/>
+          <a:chExt cx="0" cy="0"/>
+        </a:xfrm>
+      </p:grpSpPr>
+      <p:sp>
+        <p:nvSpPr>
+          <p:cNvPr id="32" name="PlaceHolder 1"/>
+          <p:cNvSpPr>
+            <a:spLocks noGrp="1"/>
+          </p:cNvSpPr>
+          <p:nvPr>
+            <p:ph type="title"/>
+          </p:nvPr>
+        </p:nvSpPr>
+        <p:spPr>
+          <a:xfrm>
+            <a:off x="504000" y="225720"/>
+            <a:ext cx="9071640" cy="946440"/>
+          </a:xfrm>
+          <a:prstGeom prst="rect">
+            <a:avLst/>
+          </a:prstGeom>
+          <a:noFill/>
+          <a:ln w="0">
+            <a:noFill/>
+          </a:ln>
+        </p:spPr>
+        <p:txBody>
+          <a:bodyPr lIns="0" rIns="0" tIns="0" bIns="0" anchor="ctr">
+            <a:spAutoFit/>
+          </a:bodyPr>
+          <a:p>
+            <a:pPr indent="0" algn="ctr">
+              <a:buNone/>
+            </a:pPr>
+            <a:r>
+              <a:rPr b="0" lang="en-US" sz="3600" strike="noStrike" u="none">
+                <a:solidFill>
+                  <a:srgbClr val="000000"/>
+                </a:solidFill>
+                <a:effectLst/>
+                <a:uFillTx/>
+                <a:latin typeface="Arial"/>
+              </a:rPr>
+              <a:t>Active Engagement with Christian Heritage</a:t>
+            </a:r>
+            <a:endParaRPr b="0" lang="en-US" sz="3600" strike="noStrike" u="none">
+              <a:solidFill>
+                <a:srgbClr val="000000"/>
+              </a:solidFill>
+              <a:effectLst/>
+              <a:uFillTx/>
+              <a:latin typeface="Arial"/>
+            </a:endParaRPr>
+          </a:p>
+        </p:txBody>
+      </p:sp>
+      <p:sp>
+        <p:nvSpPr>
+          <p:cNvPr id="33" name="PlaceHolder 2"/>
+          <p:cNvSpPr>
+            <a:spLocks noGrp="1"/>
+          </p:cNvSpPr>
+          <p:nvPr>
+            <p:ph/>
+          </p:nvPr>
+        </p:nvSpPr>
+        <p:spPr>
+          <a:xfrm>
+            <a:off x="504000" y="1326600"/>
+            <a:ext cx="9071640" cy="3288240"/>
+          </a:xfrm>
+          <a:prstGeom prst="rect">
+            <a:avLst/>
+          </a:prstGeom>
+          <a:noFill/>
+          <a:ln w="0">
+            <a:noFill/>
+          </a:ln>
+        </p:spPr>
+        <p:txBody>
+          <a:bodyPr lIns="0" rIns="0" tIns="0" bIns="0" anchor="t">
+            <a:normAutofit/>
+          </a:bodyPr>
+          <a:p>
+            <a:pPr marL="432000" indent="-324000">
+              <a:spcBef>
+                <a:spcPts val="1417"/>
+              </a:spcBef>
+              <a:buClr>
+                <a:srgbClr val="000000"/>
+              </a:buClr>
+              <a:buSzPct val="45000"/>
+              <a:buFont typeface="Wingdings" charset="2"/>
+              <a:buChar char=""/>
+            </a:pPr>
+            <a:r>
+              <a:rPr b="0" lang="en-US" sz="3200" strike="noStrike" u="none">
+                <a:solidFill>
+                  <a:srgbClr val="000000"/>
+                </a:solidFill>
+                <a:effectLst/>
+                <a:uFillTx/>
+                <a:latin typeface="Arial"/>
+              </a:rPr>
+              <a:t>Transpositions began to be primary driver of message and structure with Mother (1906-7)</a:t>
+            </a:r>
+            <a:endParaRPr b="0" lang="en-US" sz="3200" strike="noStrike" u="none">
+              <a:solidFill>
+                <a:srgbClr val="000000"/>
+              </a:solidFill>
+              <a:effectLst/>
+              <a:uFillTx/>
+              <a:latin typeface="Arial"/>
+            </a:endParaRPr>
+          </a:p>
+          <a:p>
+            <a:pPr lvl="1" marL="864000" indent="-324000">
+              <a:spcBef>
+                <a:spcPts val="1134"/>
+              </a:spcBef>
+              <a:buClr>
+                <a:srgbClr val="000000"/>
+              </a:buClr>
+              <a:buSzPct val="75000"/>
+              <a:buFont typeface="Symbol" charset="2"/>
+              <a:buChar char=""/>
+            </a:pPr>
+            <a:r>
+              <a:rPr b="0" lang="en-US" sz="2800" strike="noStrike" u="none">
+                <a:solidFill>
+                  <a:srgbClr val="000000"/>
+                </a:solidFill>
+                <a:effectLst/>
+                <a:uFillTx/>
+                <a:latin typeface="Arial"/>
+              </a:rPr>
+              <a:t>Gospels</a:t>
+            </a:r>
+            <a:endParaRPr b="0" lang="en-US" sz="2800" strike="noStrike" u="none">
+              <a:solidFill>
+                <a:srgbClr val="000000"/>
+              </a:solidFill>
+              <a:effectLst/>
+              <a:uFillTx/>
+              <a:latin typeface="Arial"/>
+            </a:endParaRPr>
+          </a:p>
+          <a:p>
+            <a:pPr lvl="1" marL="864000" indent="-324000">
+              <a:spcBef>
+                <a:spcPts val="1134"/>
+              </a:spcBef>
+              <a:buClr>
+                <a:srgbClr val="000000"/>
+              </a:buClr>
+              <a:buSzPct val="75000"/>
+              <a:buFont typeface="Symbol" charset="2"/>
+              <a:buChar char=""/>
+            </a:pPr>
+            <a:r>
+              <a:rPr b="0" lang="en-US" sz="2800" strike="noStrike" u="none">
+                <a:solidFill>
+                  <a:srgbClr val="000000"/>
+                </a:solidFill>
+                <a:effectLst/>
+                <a:uFillTx/>
+                <a:latin typeface="Arial"/>
+              </a:rPr>
+              <a:t>Acts of the Apostles</a:t>
+            </a:r>
+            <a:endParaRPr b="0" lang="en-US" sz="2800" strike="noStrike" u="none">
+              <a:solidFill>
+                <a:srgbClr val="000000"/>
+              </a:solidFill>
+              <a:effectLst/>
+              <a:uFillTx/>
+              <a:latin typeface="Arial"/>
+            </a:endParaRPr>
+          </a:p>
+          <a:p>
+            <a:pPr lvl="1" marL="864000" indent="-324000">
+              <a:spcBef>
+                <a:spcPts val="1134"/>
+              </a:spcBef>
+              <a:buClr>
+                <a:srgbClr val="000000"/>
+              </a:buClr>
+              <a:buSzPct val="75000"/>
+              <a:buFont typeface="Symbol" charset="2"/>
+              <a:buChar char=""/>
+            </a:pPr>
+            <a:r>
+              <a:rPr b="0" lang="en-US" sz="2800" strike="noStrike" u="none">
+                <a:solidFill>
+                  <a:srgbClr val="000000"/>
+                </a:solidFill>
+                <a:effectLst/>
+                <a:uFillTx/>
+                <a:latin typeface="Arial"/>
+              </a:rPr>
+              <a:t>Liturgical traditions</a:t>
+            </a:r>
+            <a:endParaRPr b="0" lang="en-US" sz="2800" strike="noStrike" u="none">
+              <a:solidFill>
+                <a:srgbClr val="000000"/>
+              </a:solidFill>
+              <a:effectLst/>
+              <a:uFillTx/>
+              <a:latin typeface="Arial"/>
+            </a:endParaRPr>
+          </a:p>
+        </p:txBody>
+      </p:sp>
+    </p:spTree>
+  </p:cSld>
+  <mc:AlternateContent>
+    <mc:Choice Requires="p14">
+      <p:transition spd="slow" p14:dur="2000"/>
+    </mc:Choice>
+    <mc:Fallback>
+      <p:transition spd="slow"/>
+    </mc:Fallback>
+  </mc:AlternateContent>
+</p:sld>
+</file>
+
+<file path=ppt/slides/slide15.xml><?xml version="1.0" encoding="utf-8"?>
+<p:sld xmlns:a="http://schemas.openxmlformats.org/drawingml/2006/main" xmlns:p="http://schemas.openxmlformats.org/presentationml/2006/main" xmlns:r="http://schemas.openxmlformats.org/officeDocument/2006/relationships" xmlns:p14="http://schemas.microsoft.com/office/powerpoint/2010/main" xmlns:p15="http://schemas.microsoft.com/office/powerpoint/2012/main" xmlns:mc="http://schemas.openxmlformats.org/markup-compatibility/2006">
+  <p:cSld>
+    <p:spTree>
+      <p:nvGrpSpPr>
+        <p:cNvPr id="1" name=""/>
+        <p:cNvGrpSpPr/>
+        <p:nvPr/>
+      </p:nvGrpSpPr>
+      <p:grpSpPr>
+        <a:xfrm>
+          <a:off x="0" y="0"/>
+          <a:ext cx="0" cy="0"/>
+          <a:chOff x="0" y="0"/>
+          <a:chExt cx="0" cy="0"/>
+        </a:xfrm>
+      </p:grpSpPr>
+      <p:sp>
+        <p:nvSpPr>
+          <p:cNvPr id="34" name="PlaceHolder 1"/>
+          <p:cNvSpPr>
+            <a:spLocks noGrp="1"/>
+          </p:cNvSpPr>
+          <p:nvPr>
+            <p:ph type="title"/>
+          </p:nvPr>
+        </p:nvSpPr>
+        <p:spPr>
+          <a:xfrm>
+            <a:off x="504000" y="225720"/>
+            <a:ext cx="9071640" cy="946440"/>
+          </a:xfrm>
+          <a:prstGeom prst="rect">
+            <a:avLst/>
+          </a:prstGeom>
+          <a:noFill/>
+          <a:ln w="0">
+            <a:noFill/>
+          </a:ln>
+        </p:spPr>
+        <p:txBody>
+          <a:bodyPr lIns="0" rIns="0" tIns="0" bIns="0" anchor="ctr">
+            <a:spAutoFit/>
+          </a:bodyPr>
+          <a:p>
+            <a:pPr indent="0" algn="ctr">
+              <a:buNone/>
+            </a:pPr>
+            <a:r>
+              <a:rPr b="0" lang="en-US" sz="3600" strike="noStrike" u="none">
+                <a:solidFill>
+                  <a:srgbClr val="000000"/>
+                </a:solidFill>
+                <a:effectLst/>
+                <a:uFillTx/>
+                <a:latin typeface="Arial"/>
+              </a:rPr>
+              <a:t>Active Engagement with Christian Heritage</a:t>
+            </a:r>
+            <a:endParaRPr b="0" lang="en-US" sz="3600" strike="noStrike" u="none">
+              <a:solidFill>
+                <a:srgbClr val="000000"/>
+              </a:solidFill>
+              <a:effectLst/>
+              <a:uFillTx/>
+              <a:latin typeface="Arial"/>
+            </a:endParaRPr>
+          </a:p>
+        </p:txBody>
+      </p:sp>
+      <p:sp>
+        <p:nvSpPr>
+          <p:cNvPr id="35" name="PlaceHolder 2"/>
+          <p:cNvSpPr>
+            <a:spLocks noGrp="1"/>
+          </p:cNvSpPr>
+          <p:nvPr>
+            <p:ph/>
+          </p:nvPr>
+        </p:nvSpPr>
+        <p:spPr>
+          <a:xfrm>
+            <a:off x="504000" y="1326600"/>
+            <a:ext cx="9071640" cy="3288240"/>
+          </a:xfrm>
+          <a:prstGeom prst="rect">
+            <a:avLst/>
+          </a:prstGeom>
+          <a:noFill/>
+          <a:ln w="0">
+            <a:noFill/>
+          </a:ln>
+        </p:spPr>
+        <p:txBody>
+          <a:bodyPr lIns="0" rIns="0" tIns="0" bIns="0" anchor="t">
+            <a:normAutofit/>
+          </a:bodyPr>
+          <a:p>
+            <a:pPr marL="432000" indent="-324000">
+              <a:spcBef>
+                <a:spcPts val="1417"/>
+              </a:spcBef>
+              <a:buClr>
+                <a:srgbClr val="000000"/>
+              </a:buClr>
+              <a:buSzPct val="45000"/>
+              <a:buFont typeface="Wingdings" charset="2"/>
+              <a:buChar char=""/>
+            </a:pPr>
+            <a:r>
+              <a:rPr b="0" lang="en-US" sz="3200" strike="noStrike" u="none">
+                <a:solidFill>
+                  <a:srgbClr val="000000"/>
+                </a:solidFill>
+                <a:effectLst/>
+                <a:uFillTx/>
+                <a:latin typeface="Arial"/>
+              </a:rPr>
+              <a:t>Confession became an existential testament to new gospel (MG’s apocrypha)</a:t>
+            </a:r>
+            <a:endParaRPr b="0" lang="en-US" sz="3200" strike="noStrike" u="none">
+              <a:solidFill>
+                <a:srgbClr val="000000"/>
+              </a:solidFill>
+              <a:effectLst/>
+              <a:uFillTx/>
+              <a:latin typeface="Arial"/>
+            </a:endParaRPr>
+          </a:p>
+          <a:p>
+            <a:pPr lvl="1" marL="864000" indent="-324000">
+              <a:spcBef>
+                <a:spcPts val="1134"/>
+              </a:spcBef>
+              <a:buClr>
+                <a:srgbClr val="000000"/>
+              </a:buClr>
+              <a:buSzPct val="75000"/>
+              <a:buFont typeface="Symbol" charset="2"/>
+              <a:buChar char=""/>
+            </a:pPr>
+            <a:r>
+              <a:rPr b="0" lang="en-US" sz="2800" strike="noStrike" u="none">
+                <a:solidFill>
+                  <a:srgbClr val="000000"/>
+                </a:solidFill>
+                <a:effectLst/>
+                <a:uFillTx/>
+                <a:latin typeface="Arial"/>
+              </a:rPr>
+              <a:t>Confession genre</a:t>
+            </a:r>
+            <a:endParaRPr b="0" lang="en-US" sz="2800" strike="noStrike" u="none">
+              <a:solidFill>
+                <a:srgbClr val="000000"/>
+              </a:solidFill>
+              <a:effectLst/>
+              <a:uFillTx/>
+              <a:latin typeface="Arial"/>
+            </a:endParaRPr>
+          </a:p>
+          <a:p>
+            <a:pPr lvl="1" marL="864000" indent="-324000">
+              <a:spcBef>
+                <a:spcPts val="1134"/>
+              </a:spcBef>
+              <a:buClr>
+                <a:srgbClr val="000000"/>
+              </a:buClr>
+              <a:buSzPct val="75000"/>
+              <a:buFont typeface="Symbol" charset="2"/>
+              <a:buChar char=""/>
+            </a:pPr>
+            <a:r>
+              <a:rPr b="0" lang="en-US" sz="2800" strike="noStrike" u="none">
+                <a:solidFill>
+                  <a:srgbClr val="000000"/>
+                </a:solidFill>
+                <a:effectLst/>
+                <a:uFillTx/>
+                <a:latin typeface="Arial"/>
+              </a:rPr>
+              <a:t>Godbearer Among the Torments [Хождение Богородицы по мукам]</a:t>
+            </a:r>
+            <a:endParaRPr b="0" lang="en-US" sz="2800" strike="noStrike" u="none">
+              <a:solidFill>
+                <a:srgbClr val="000000"/>
+              </a:solidFill>
+              <a:effectLst/>
+              <a:uFillTx/>
+              <a:latin typeface="Arial"/>
+            </a:endParaRPr>
+          </a:p>
+        </p:txBody>
+      </p:sp>
+    </p:spTree>
+  </p:cSld>
+  <mc:AlternateContent>
+    <mc:Choice Requires="p14">
+      <p:transition spd="slow" p14:dur="2000"/>
+    </mc:Choice>
+    <mc:Fallback>
+      <p:transition spd="slow"/>
+    </mc:Fallback>
+  </mc:AlternateContent>
+</p:sld>
+</file>
+
+<file path=ppt/slides/slide16.xml><?xml version="1.0" encoding="utf-8"?>
+<p:sld xmlns:a="http://schemas.openxmlformats.org/drawingml/2006/main" xmlns:p="http://schemas.openxmlformats.org/presentationml/2006/main" xmlns:r="http://schemas.openxmlformats.org/officeDocument/2006/relationships" xmlns:p14="http://schemas.microsoft.com/office/powerpoint/2010/main" xmlns:p15="http://schemas.microsoft.com/office/powerpoint/2012/main" xmlns:mc="http://schemas.openxmlformats.org/markup-compatibility/2006">
+  <p:cSld>
+    <p:spTree>
+      <p:nvGrpSpPr>
+        <p:cNvPr id="1" name=""/>
+        <p:cNvGrpSpPr/>
+        <p:nvPr/>
+      </p:nvGrpSpPr>
+      <p:grpSpPr>
+        <a:xfrm>
+          <a:off x="0" y="0"/>
+          <a:ext cx="0" cy="0"/>
+          <a:chOff x="0" y="0"/>
+          <a:chExt cx="0" cy="0"/>
+        </a:xfrm>
+      </p:grpSpPr>
+      <p:sp>
+        <p:nvSpPr>
+          <p:cNvPr id="36" name="PlaceHolder 1"/>
+          <p:cNvSpPr>
+            <a:spLocks noGrp="1"/>
+          </p:cNvSpPr>
+          <p:nvPr>
+            <p:ph type="subTitle"/>
+          </p:nvPr>
+        </p:nvSpPr>
+        <p:spPr>
+          <a:xfrm>
+            <a:off x="504000" y="226080"/>
+            <a:ext cx="9071640" cy="4388400"/>
+          </a:xfrm>
+          <a:prstGeom prst="rect">
+            <a:avLst/>
+          </a:prstGeom>
+          <a:noFill/>
+          <a:ln w="0">
+            <a:noFill/>
+          </a:ln>
+        </p:spPr>
+        <p:txBody>
+          <a:bodyPr lIns="0" rIns="0" tIns="0" bIns="0" anchor="ctr">
+            <a:spAutoFit/>
+          </a:bodyPr>
+          <a:p>
+            <a:pPr algn="ctr"/>
+            <a:r>
+              <a:rPr b="0" lang="en-US" sz="3200" strike="noStrike" u="none">
+                <a:solidFill>
+                  <a:srgbClr val="000000"/>
+                </a:solidFill>
+                <a:effectLst/>
+                <a:uFillTx/>
+                <a:latin typeface="Arial"/>
+              </a:rPr>
               <a:t>The Future</a:t>
             </a:r>
+            <a:endParaRPr b="0" lang="en-US" sz="3200" strike="noStrike" u="none">
+              <a:solidFill>
+                <a:srgbClr val="000000"/>
+              </a:solidFill>
+              <a:effectLst/>
+              <a:uFillTx/>
+              <a:latin typeface="Arial"/>
+            </a:endParaRPr>
+          </a:p>
+        </p:txBody>
+      </p:sp>
+    </p:spTree>
+  </p:cSld>
+  <mc:AlternateContent>
+    <mc:Choice Requires="p14">
+      <p:transition spd="slow" p14:dur="2000"/>
+    </mc:Choice>
+    <mc:Fallback>
+      <p:transition spd="slow"/>
+    </mc:Fallback>
+  </mc:AlternateContent>
+</p:sld>
+</file>
+
+<file path=ppt/slides/slide17.xml><?xml version="1.0" encoding="utf-8"?>
+<p:sld xmlns:a="http://schemas.openxmlformats.org/drawingml/2006/main" xmlns:p="http://schemas.openxmlformats.org/presentationml/2006/main" xmlns:r="http://schemas.openxmlformats.org/officeDocument/2006/relationships" xmlns:p14="http://schemas.microsoft.com/office/powerpoint/2010/main" xmlns:p15="http://schemas.microsoft.com/office/powerpoint/2012/main" xmlns:mc="http://schemas.openxmlformats.org/markup-compatibility/2006">
+  <p:cSld>
+    <p:spTree>
+      <p:nvGrpSpPr>
+        <p:cNvPr id="1" name=""/>
+        <p:cNvGrpSpPr/>
+        <p:nvPr/>
+      </p:nvGrpSpPr>
+      <p:grpSpPr>
+        <a:xfrm>
+          <a:off x="0" y="0"/>
+          <a:ext cx="0" cy="0"/>
+          <a:chOff x="0" y="0"/>
+          <a:chExt cx="0" cy="0"/>
+        </a:xfrm>
+      </p:grpSpPr>
+      <p:sp>
+        <p:nvSpPr>
+          <p:cNvPr id="37" name="PlaceHolder 1"/>
+          <p:cNvSpPr>
+            <a:spLocks noGrp="1"/>
+          </p:cNvSpPr>
+          <p:nvPr>
+            <p:ph type="title"/>
+          </p:nvPr>
+        </p:nvSpPr>
+        <p:spPr>
+          <a:xfrm>
+            <a:off x="504000" y="226080"/>
+            <a:ext cx="9071640" cy="946440"/>
+          </a:xfrm>
+          <a:prstGeom prst="rect">
+            <a:avLst/>
+          </a:prstGeom>
+          <a:noFill/>
+          <a:ln w="0">
+            <a:noFill/>
+          </a:ln>
+        </p:spPr>
+        <p:txBody>
+          <a:bodyPr lIns="0" rIns="0" tIns="0" bIns="0" anchor="ctr">
+            <a:spAutoFit/>
+          </a:bodyPr>
+          <a:p>
+            <a:pPr indent="0" algn="ctr">
+              <a:buNone/>
+            </a:pPr>
+            <a:r>
+              <a:rPr b="0" lang="en-US" sz="4400" strike="noStrike" u="none">
+                <a:solidFill>
+                  <a:srgbClr val="000000"/>
+                </a:solidFill>
+                <a:effectLst/>
+                <a:uFillTx/>
+                <a:latin typeface="Arial"/>
+              </a:rPr>
+              <a:t>Implications</a:t>
+            </a:r>
+            <a:endParaRPr b="0" lang="en-US" sz="4400" strike="noStrike" u="none">
+              <a:solidFill>
+                <a:srgbClr val="000000"/>
+              </a:solidFill>
+              <a:effectLst/>
+              <a:uFillTx/>
+              <a:latin typeface="Arial"/>
+            </a:endParaRPr>
+          </a:p>
+        </p:txBody>
+      </p:sp>
+      <p:sp>
+        <p:nvSpPr>
+          <p:cNvPr id="38" name="PlaceHolder 2"/>
+          <p:cNvSpPr>
+            <a:spLocks noGrp="1"/>
+          </p:cNvSpPr>
+          <p:nvPr>
+            <p:ph/>
+          </p:nvPr>
+        </p:nvSpPr>
+        <p:spPr>
+          <a:xfrm>
+            <a:off x="504000" y="1326600"/>
+            <a:ext cx="9071640" cy="3288240"/>
+          </a:xfrm>
+          <a:prstGeom prst="rect">
+            <a:avLst/>
+          </a:prstGeom>
+          <a:noFill/>
+          <a:ln w="0">
+            <a:noFill/>
+          </a:ln>
+        </p:spPr>
+        <p:txBody>
+          <a:bodyPr lIns="0" rIns="0" tIns="0" bIns="0" anchor="t">
+            <a:normAutofit/>
+          </a:bodyPr>
+          <a:p>
+            <a:pPr indent="0">
+              <a:spcBef>
+                <a:spcPts val="1417"/>
+              </a:spcBef>
+              <a:buNone/>
+            </a:pPr>
+            <a:endParaRPr b="0" lang="en-US" sz="3200" strike="noStrike" u="none">
+              <a:solidFill>
+                <a:srgbClr val="000000"/>
+              </a:solidFill>
+              <a:effectLst/>
+              <a:uFillTx/>
+              <a:latin typeface="Arial"/>
+            </a:endParaRPr>
+          </a:p>
+        </p:txBody>
+      </p:sp>
+    </p:spTree>
+  </p:cSld>
+  <mc:AlternateContent>
+    <mc:Choice Requires="p14">
+      <p:transition spd="slow" p14:dur="2000"/>
+    </mc:Choice>
+    <mc:Fallback>
+      <p:transition spd="slow"/>
+    </mc:Fallback>
+  </mc:AlternateContent>
+</p:sld>
+</file>
+
+<file path=ppt/slides/slide18.xml><?xml version="1.0" encoding="utf-8"?>
+<p:sld xmlns:a="http://schemas.openxmlformats.org/drawingml/2006/main" xmlns:p="http://schemas.openxmlformats.org/presentationml/2006/main" xmlns:r="http://schemas.openxmlformats.org/officeDocument/2006/relationships" xmlns:p14="http://schemas.microsoft.com/office/powerpoint/2010/main" xmlns:p15="http://schemas.microsoft.com/office/powerpoint/2012/main" xmlns:mc="http://schemas.openxmlformats.org/markup-compatibility/2006">
+  <p:cSld>
+    <p:spTree>
+      <p:nvGrpSpPr>
+        <p:cNvPr id="1" name=""/>
+        <p:cNvGrpSpPr/>
+        <p:nvPr/>
+      </p:nvGrpSpPr>
+      <p:grpSpPr>
+        <a:xfrm>
+          <a:off x="0" y="0"/>
+          <a:ext cx="0" cy="0"/>
+          <a:chOff x="0" y="0"/>
+          <a:chExt cx="0" cy="0"/>
+        </a:xfrm>
+      </p:grpSpPr>
+      <p:sp>
+        <p:nvSpPr>
+          <p:cNvPr id="39" name="PlaceHolder 1"/>
+          <p:cNvSpPr>
+            <a:spLocks noGrp="1"/>
+          </p:cNvSpPr>
+          <p:nvPr>
+            <p:ph type="title"/>
+          </p:nvPr>
+        </p:nvSpPr>
+        <p:spPr>
+          <a:xfrm>
+            <a:off x="504000" y="226080"/>
+            <a:ext cx="9071640" cy="946440"/>
+          </a:xfrm>
+          <a:prstGeom prst="rect">
+            <a:avLst/>
+          </a:prstGeom>
+          <a:noFill/>
+          <a:ln w="0">
+            <a:noFill/>
+          </a:ln>
+        </p:spPr>
+        <p:txBody>
+          <a:bodyPr lIns="0" rIns="0" tIns="0" bIns="0" anchor="ctr">
+            <a:spAutoFit/>
+          </a:bodyPr>
+          <a:p>
+            <a:pPr indent="0" algn="ctr">
+              <a:buNone/>
+            </a:pPr>
+            <a:r>
+              <a:rPr b="0" lang="en-US" sz="4400" strike="noStrike" u="none">
+                <a:solidFill>
+                  <a:srgbClr val="000000"/>
+                </a:solidFill>
+                <a:effectLst/>
+                <a:uFillTx/>
+                <a:latin typeface="Arial"/>
+              </a:rPr>
+              <a:t>Future Research &amp; Chapters</a:t>
+            </a:r>
+            <a:endParaRPr b="0" lang="en-US" sz="4400" strike="noStrike" u="none">
+              <a:solidFill>
+                <a:srgbClr val="000000"/>
+              </a:solidFill>
+              <a:effectLst/>
+              <a:uFillTx/>
+              <a:latin typeface="Arial"/>
+            </a:endParaRPr>
+          </a:p>
+        </p:txBody>
+      </p:sp>
+      <p:sp>
+        <p:nvSpPr>
+          <p:cNvPr id="40" name="PlaceHolder 2"/>
+          <p:cNvSpPr>
+            <a:spLocks noGrp="1"/>
+          </p:cNvSpPr>
+          <p:nvPr>
+            <p:ph/>
+          </p:nvPr>
+        </p:nvSpPr>
+        <p:spPr>
+          <a:xfrm>
+            <a:off x="504000" y="1326600"/>
+            <a:ext cx="9071640" cy="3288240"/>
+          </a:xfrm>
+          <a:prstGeom prst="rect">
+            <a:avLst/>
+          </a:prstGeom>
+          <a:noFill/>
+          <a:ln w="0">
+            <a:noFill/>
+          </a:ln>
+        </p:spPr>
+        <p:txBody>
+          <a:bodyPr lIns="0" rIns="0" tIns="0" bIns="0" anchor="t">
+            <a:normAutofit/>
+          </a:bodyPr>
+          <a:p>
+            <a:pPr indent="0">
+              <a:spcBef>
+                <a:spcPts val="1417"/>
+              </a:spcBef>
+              <a:buNone/>
+            </a:pPr>
             <a:endParaRPr b="0" lang="en-US" sz="3200" strike="noStrike" u="none">
               <a:solidFill>
                 <a:srgbClr val="000000"/>
@@ -1891,7 +3115,7 @@
                 <a:uFillTx/>
                 <a:latin typeface="Arial"/>
               </a:rPr>
-              <a:t>Implications for scholarly views on MG, godbuilding, Italy period, IH</a:t>
+              <a:t>DH</a:t>
             </a:r>
             <a:endParaRPr b="0" lang="en-US" sz="2800" strike="noStrike" u="none">
               <a:solidFill>
@@ -1955,7 +3179,7 @@
                 <a:uFillTx/>
                 <a:latin typeface="Arial"/>
               </a:rPr>
-              <a:t>Remaining questions, archival work in Italy again and hopefully Russia somehow someday</a:t>
+              <a:t>Implications for scholarly views on MG, godbuilding, Italy period, IH</a:t>
             </a:r>
             <a:endParaRPr b="0" lang="en-US" sz="2800" strike="noStrike" u="none">
               <a:solidFill>
@@ -1987,7 +3211,7 @@
                 <a:uFillTx/>
                 <a:latin typeface="Arial"/>
               </a:rPr>
-              <a:t>Further chapters:</a:t>
+              <a:t>Remaining questions, archival work in Italy again and hopefully Russia somehow someday</a:t>
             </a:r>
             <a:endParaRPr b="0" lang="en-US" sz="2800" strike="noStrike" u="none">
               <a:solidFill>
@@ -2070,7 +3294,7 @@
                 <a:uFillTx/>
                 <a:latin typeface="Arial"/>
               </a:rPr>
-              <a:t>BLUF</a:t>
+              <a:t>B.L.U.F.</a:t>
             </a:r>
             <a:endParaRPr b="0" lang="en-US" sz="4400" strike="noStrike" u="none">
               <a:solidFill>
@@ -2134,7 +3358,135 @@
                 <a:uFillTx/>
                 <a:latin typeface="Arial"/>
               </a:rPr>
-              <a:t> explains where, when, how, and why Maksim Gor’kii recast Christian texts and traditions to push society toward a spiritual-socialist restructuring.</a:t>
+              <a:t> explains </a:t>
+            </a:r>
+            <a:endParaRPr b="0" lang="en-US" sz="3200" strike="noStrike" u="none">
+              <a:solidFill>
+                <a:srgbClr val="000000"/>
+              </a:solidFill>
+              <a:effectLst/>
+              <a:uFillTx/>
+              <a:latin typeface="Arial"/>
+            </a:endParaRPr>
+          </a:p>
+          <a:p>
+            <a:pPr marL="216000" indent="-216000" algn="ctr">
+              <a:buClr>
+                <a:srgbClr val="000000"/>
+              </a:buClr>
+              <a:buSzPct val="45000"/>
+              <a:buFont typeface="Symbol" charset="2"/>
+              <a:buChar char=""/>
+            </a:pPr>
+            <a:r>
+              <a:rPr b="0" lang="en-US" sz="3200" strike="noStrike" u="none">
+                <a:solidFill>
+                  <a:srgbClr val="000000"/>
+                </a:solidFill>
+                <a:effectLst/>
+                <a:uFillTx/>
+                <a:latin typeface="Arial"/>
+                <a:ea typeface="Source Han Sans CN"/>
+              </a:rPr>
+              <a:t>where, when, why, and how</a:t>
+            </a:r>
+            <a:r>
+              <a:rPr b="0" lang="en-US" sz="3200" strike="noStrike" u="none">
+                <a:solidFill>
+                  <a:srgbClr val="000000"/>
+                </a:solidFill>
+                <a:effectLst/>
+                <a:uFillTx/>
+                <a:latin typeface="Arial"/>
+              </a:rPr>
+              <a:t> Maksim Gor’kii (MG)</a:t>
+            </a:r>
+            <a:endParaRPr b="0" lang="en-US" sz="3200" strike="noStrike" u="none">
+              <a:solidFill>
+                <a:srgbClr val="000000"/>
+              </a:solidFill>
+              <a:effectLst/>
+              <a:uFillTx/>
+              <a:latin typeface="Arial"/>
+            </a:endParaRPr>
+          </a:p>
+          <a:p>
+            <a:pPr marL="216000" indent="-216000" algn="ctr">
+              <a:buClr>
+                <a:srgbClr val="000000"/>
+              </a:buClr>
+              <a:buSzPct val="45000"/>
+              <a:buFont typeface="Symbol" charset="2"/>
+              <a:buChar char=""/>
+            </a:pPr>
+            <a:r>
+              <a:rPr b="0" lang="en-US" sz="3200" strike="noStrike" u="none">
+                <a:solidFill>
+                  <a:srgbClr val="000000"/>
+                </a:solidFill>
+                <a:effectLst/>
+                <a:uFillTx/>
+                <a:latin typeface="Arial"/>
+              </a:rPr>
+              <a:t>recasts Christian texts and traditions </a:t>
+            </a:r>
+            <a:endParaRPr b="0" lang="en-US" sz="3200" strike="noStrike" u="none">
+              <a:solidFill>
+                <a:srgbClr val="000000"/>
+              </a:solidFill>
+              <a:effectLst/>
+              <a:uFillTx/>
+              <a:latin typeface="Arial"/>
+            </a:endParaRPr>
+          </a:p>
+          <a:p>
+            <a:pPr marL="216000" indent="-216000" algn="ctr">
+              <a:buClr>
+                <a:srgbClr val="000000"/>
+              </a:buClr>
+              <a:buSzPct val="45000"/>
+              <a:buFont typeface="Symbol" charset="2"/>
+              <a:buChar char=""/>
+            </a:pPr>
+            <a:r>
+              <a:rPr b="0" lang="en-US" sz="3200" strike="noStrike" u="none">
+                <a:solidFill>
+                  <a:srgbClr val="000000"/>
+                </a:solidFill>
+                <a:effectLst/>
+                <a:uFillTx/>
+                <a:latin typeface="Arial"/>
+              </a:rPr>
+              <a:t>as a rhetorical device for </a:t>
+            </a:r>
+            <a:endParaRPr b="0" lang="en-US" sz="3200" strike="noStrike" u="none">
+              <a:solidFill>
+                <a:srgbClr val="000000"/>
+              </a:solidFill>
+              <a:effectLst/>
+              <a:uFillTx/>
+              <a:latin typeface="Arial"/>
+            </a:endParaRPr>
+          </a:p>
+          <a:p>
+            <a:pPr marL="216000" indent="-216000" algn="ctr">
+              <a:buClr>
+                <a:srgbClr val="000000"/>
+              </a:buClr>
+              <a:buSzPct val="45000"/>
+              <a:buFont typeface="Symbol" charset="2"/>
+              <a:buChar char=""/>
+            </a:pPr>
+            <a:r>
+              <a:rPr b="0" lang="en-US" sz="3200" strike="noStrike" u="none">
+                <a:solidFill>
+                  <a:srgbClr val="000000"/>
+                </a:solidFill>
+                <a:effectLst/>
+                <a:uFillTx/>
+                <a:latin typeface="Arial"/>
+              </a:rPr>
+              <a:t>a spiritual-socialist revolution in Russia.</a:t>
             </a:r>
             <a:endParaRPr b="0" lang="en-US" sz="3200" strike="noStrike" u="none">
               <a:solidFill>
@@ -2184,13 +3536,13 @@
             <a:spLocks noGrp="1"/>
           </p:cNvSpPr>
           <p:nvPr>
-            <p:ph type="subTitle"/>
+            <p:ph type="title"/>
           </p:nvPr>
         </p:nvSpPr>
         <p:spPr>
           <a:xfrm>
             <a:off x="504000" y="226080"/>
-            <a:ext cx="9071640" cy="4388400"/>
+            <a:ext cx="9071640" cy="946440"/>
           </a:xfrm>
           <a:prstGeom prst="rect">
             <a:avLst/>
@@ -2205,7 +3557,59 @@
             <a:spAutoFit/>
           </a:bodyPr>
           <a:p>
-            <a:pPr algn="ctr"/>
+            <a:pPr indent="0" algn="ctr">
+              <a:buNone/>
+            </a:pPr>
+            <a:endParaRPr b="0" lang="en-US" sz="4400" strike="noStrike" u="none">
+              <a:solidFill>
+                <a:srgbClr val="000000"/>
+              </a:solidFill>
+              <a:effectLst/>
+              <a:uFillTx/>
+              <a:latin typeface="Arial"/>
+            </a:endParaRPr>
+          </a:p>
+        </p:txBody>
+      </p:sp>
+      <p:sp>
+        <p:nvSpPr>
+          <p:cNvPr id="16" name="PlaceHolder 2"/>
+          <p:cNvSpPr>
+            <a:spLocks noGrp="1"/>
+          </p:cNvSpPr>
+          <p:nvPr>
+            <p:ph/>
+          </p:nvPr>
+        </p:nvSpPr>
+        <p:spPr>
+          <a:xfrm>
+            <a:off x="504000" y="1326600"/>
+            <a:ext cx="9071640" cy="3288240"/>
+          </a:xfrm>
+          <a:prstGeom prst="rect">
+            <a:avLst/>
+          </a:prstGeom>
+          <a:noFill/>
+          <a:ln w="0">
+            <a:noFill/>
+          </a:ln>
+        </p:spPr>
+        <p:txBody>
+          <a:bodyPr lIns="0" rIns="0" tIns="0" bIns="0" anchor="t">
+            <a:normAutofit fontScale="70000" lnSpcReduction="19999"/>
+          </a:bodyPr>
+          <a:p>
+            <a:pPr marL="432000" indent="-324000">
+              <a:spcBef>
+                <a:spcPts val="1417"/>
+              </a:spcBef>
+              <a:buClr>
+                <a:srgbClr val="000000"/>
+              </a:buClr>
+              <a:buSzPct val="45000"/>
+              <a:buFont typeface="Wingdings" charset="2"/>
+              <a:buChar char=""/>
+            </a:pPr>
             <a:r>
               <a:rPr b="0" lang="en-US" sz="3200" strike="noStrike" u="none">
                 <a:solidFill>
@@ -2215,7 +3619,231 @@
                 <a:uFillTx/>
                 <a:latin typeface="Arial"/>
               </a:rPr>
-              <a:t>The Idea</a:t>
+              <a:t>Godbuilding definition</a:t>
+            </a:r>
+            <a:endParaRPr b="0" lang="en-US" sz="3200" strike="noStrike" u="none">
+              <a:solidFill>
+                <a:srgbClr val="000000"/>
+              </a:solidFill>
+              <a:effectLst/>
+              <a:uFillTx/>
+              <a:latin typeface="Arial"/>
+            </a:endParaRPr>
+          </a:p>
+          <a:p>
+            <a:pPr marL="432000" indent="-324000">
+              <a:spcBef>
+                <a:spcPts val="1417"/>
+              </a:spcBef>
+              <a:buClr>
+                <a:srgbClr val="000000"/>
+              </a:buClr>
+              <a:buSzPct val="45000"/>
+              <a:buFont typeface="Wingdings" charset="2"/>
+              <a:buChar char=""/>
+            </a:pPr>
+            <a:r>
+              <a:rPr b="0" lang="en-US" sz="3200" strike="noStrike" u="none">
+                <a:solidFill>
+                  <a:srgbClr val="000000"/>
+                </a:solidFill>
+                <a:effectLst/>
+                <a:uFillTx/>
+                <a:latin typeface="Arial"/>
+              </a:rPr>
+              <a:t>Institutional vs material Orthodox culture</a:t>
+            </a:r>
+            <a:endParaRPr b="0" lang="en-US" sz="3200" strike="noStrike" u="none">
+              <a:solidFill>
+                <a:srgbClr val="000000"/>
+              </a:solidFill>
+              <a:effectLst/>
+              <a:uFillTx/>
+              <a:latin typeface="Arial"/>
+            </a:endParaRPr>
+          </a:p>
+          <a:p>
+            <a:pPr marL="432000" indent="-324000">
+              <a:spcBef>
+                <a:spcPts val="1417"/>
+              </a:spcBef>
+              <a:buClr>
+                <a:srgbClr val="000000"/>
+              </a:buClr>
+              <a:buSzPct val="45000"/>
+              <a:buFont typeface="Wingdings" charset="2"/>
+              <a:buChar char=""/>
+            </a:pPr>
+            <a:r>
+              <a:rPr b="0" lang="en-US" sz="3200" strike="noStrike" u="none">
+                <a:solidFill>
+                  <a:srgbClr val="000000"/>
+                </a:solidFill>
+                <a:effectLst/>
+                <a:uFillTx/>
+                <a:latin typeface="Arial"/>
+              </a:rPr>
+              <a:t>Move description of chapters to preface</a:t>
+            </a:r>
+            <a:endParaRPr b="0" lang="en-US" sz="3200" strike="noStrike" u="none">
+              <a:solidFill>
+                <a:srgbClr val="000000"/>
+              </a:solidFill>
+              <a:effectLst/>
+              <a:uFillTx/>
+              <a:latin typeface="Arial"/>
+            </a:endParaRPr>
+          </a:p>
+          <a:p>
+            <a:pPr marL="432000" indent="-324000">
+              <a:spcBef>
+                <a:spcPts val="1417"/>
+              </a:spcBef>
+              <a:buClr>
+                <a:srgbClr val="000000"/>
+              </a:buClr>
+              <a:buSzPct val="45000"/>
+              <a:buFont typeface="Wingdings" charset="2"/>
+              <a:buChar char=""/>
+            </a:pPr>
+            <a:r>
+              <a:rPr b="0" lang="en-US" sz="3200" strike="noStrike" u="none">
+                <a:solidFill>
+                  <a:srgbClr val="000000"/>
+                </a:solidFill>
+                <a:effectLst/>
+                <a:uFillTx/>
+                <a:latin typeface="Arial"/>
+              </a:rPr>
+              <a:t>Victory over Charles XII Swedes for Finland or delete?</a:t>
+            </a:r>
+            <a:endParaRPr b="0" lang="en-US" sz="3200" strike="noStrike" u="none">
+              <a:solidFill>
+                <a:srgbClr val="000000"/>
+              </a:solidFill>
+              <a:effectLst/>
+              <a:uFillTx/>
+              <a:latin typeface="Arial"/>
+            </a:endParaRPr>
+          </a:p>
+          <a:p>
+            <a:pPr marL="432000" indent="-324000">
+              <a:spcBef>
+                <a:spcPts val="1417"/>
+              </a:spcBef>
+              <a:buClr>
+                <a:srgbClr val="000000"/>
+              </a:buClr>
+              <a:buSzPct val="45000"/>
+              <a:buFont typeface="Wingdings" charset="2"/>
+              <a:buChar char=""/>
+            </a:pPr>
+            <a:r>
+              <a:rPr b="0" lang="en-US" sz="3200" strike="noStrike" u="none">
+                <a:solidFill>
+                  <a:srgbClr val="000000"/>
+                </a:solidFill>
+                <a:effectLst/>
+                <a:uFillTx/>
+                <a:latin typeface="Arial"/>
+              </a:rPr>
+              <a:t>Nicholas I’s accession not coronation, reverse sentence structure</a:t>
+            </a:r>
+            <a:endParaRPr b="0" lang="en-US" sz="3200" strike="noStrike" u="none">
+              <a:solidFill>
+                <a:srgbClr val="000000"/>
+              </a:solidFill>
+              <a:effectLst/>
+              <a:uFillTx/>
+              <a:latin typeface="Arial"/>
+            </a:endParaRPr>
+          </a:p>
+          <a:p>
+            <a:pPr marL="432000" indent="-324000">
+              <a:spcBef>
+                <a:spcPts val="1417"/>
+              </a:spcBef>
+              <a:buClr>
+                <a:srgbClr val="000000"/>
+              </a:buClr>
+              <a:buSzPct val="45000"/>
+              <a:buFont typeface="Wingdings" charset="2"/>
+              <a:buChar char=""/>
+            </a:pPr>
+            <a:r>
+              <a:rPr b="0" lang="en-US" sz="3200" strike="noStrike" u="none">
+                <a:solidFill>
+                  <a:srgbClr val="000000"/>
+                </a:solidFill>
+                <a:effectLst/>
+                <a:uFillTx/>
+                <a:latin typeface="Arial"/>
+              </a:rPr>
+              <a:t>Sobornost’ in slavophilism, optional tsar?</a:t>
+            </a:r>
+            <a:endParaRPr b="0" lang="en-US" sz="3200" strike="noStrike" u="none">
+              <a:solidFill>
+                <a:srgbClr val="000000"/>
+              </a:solidFill>
+              <a:effectLst/>
+              <a:uFillTx/>
+              <a:latin typeface="Arial"/>
+            </a:endParaRPr>
+          </a:p>
+          <a:p>
+            <a:pPr marL="432000" indent="-324000">
+              <a:spcBef>
+                <a:spcPts val="1417"/>
+              </a:spcBef>
+              <a:buClr>
+                <a:srgbClr val="000000"/>
+              </a:buClr>
+              <a:buSzPct val="45000"/>
+              <a:buFont typeface="Wingdings" charset="2"/>
+              <a:buChar char=""/>
+            </a:pPr>
+            <a:r>
+              <a:rPr b="0" lang="en-US" sz="3200" strike="noStrike" u="none">
+                <a:solidFill>
+                  <a:srgbClr val="000000"/>
+                </a:solidFill>
+                <a:effectLst/>
+                <a:uFillTx/>
+                <a:latin typeface="Arial"/>
+              </a:rPr>
+              <a:t>Take away from Foma</a:t>
+            </a:r>
+            <a:endParaRPr b="0" lang="en-US" sz="3200" strike="noStrike" u="none">
+              <a:solidFill>
+                <a:srgbClr val="000000"/>
+              </a:solidFill>
+              <a:effectLst/>
+              <a:uFillTx/>
+              <a:latin typeface="Arial"/>
+            </a:endParaRPr>
+          </a:p>
+          <a:p>
+            <a:pPr marL="432000" indent="-324000">
+              <a:spcBef>
+                <a:spcPts val="1417"/>
+              </a:spcBef>
+              <a:buClr>
+                <a:srgbClr val="000000"/>
+              </a:buClr>
+              <a:buSzPct val="45000"/>
+              <a:buFont typeface="Wingdings" charset="2"/>
+              <a:buChar char=""/>
+            </a:pPr>
+            <a:r>
+              <a:rPr b="0" lang="en-US" sz="3200" strike="noStrike" u="none">
+                <a:solidFill>
+                  <a:srgbClr val="000000"/>
+                </a:solidFill>
+                <a:effectLst/>
+                <a:uFillTx/>
+                <a:latin typeface="Arial"/>
+              </a:rPr>
+              <a:t>Map of confession wandering</a:t>
             </a:r>
             <a:endParaRPr b="0" lang="en-US" sz="3200" strike="noStrike" u="none">
               <a:solidFill>
@@ -2260,18 +3888,18 @@
       </p:grpSpPr>
       <p:sp>
         <p:nvSpPr>
-          <p:cNvPr id="16" name="PlaceHolder 1"/>
+          <p:cNvPr id="17" name="PlaceHolder 1"/>
           <p:cNvSpPr>
             <a:spLocks noGrp="1"/>
           </p:cNvSpPr>
           <p:nvPr>
-            <p:ph type="title"/>
+            <p:ph type="subTitle"/>
           </p:nvPr>
         </p:nvSpPr>
         <p:spPr>
           <a:xfrm>
             <a:off x="504000" y="226080"/>
-            <a:ext cx="9071640" cy="946440"/>
+            <a:ext cx="9071640" cy="4388400"/>
           </a:xfrm>
           <a:prstGeom prst="rect">
             <a:avLst/>
@@ -2286,70 +3914,7 @@
             <a:spAutoFit/>
           </a:bodyPr>
           <a:p>
-            <a:pPr indent="0" algn="ctr">
-              <a:buNone/>
-            </a:pPr>
-            <a:r>
-              <a:rPr b="0" lang="en-US" sz="4400" strike="noStrike" u="none">
-                <a:solidFill>
-                  <a:srgbClr val="000000"/>
-                </a:solidFill>
-                <a:effectLst/>
-                <a:uFillTx/>
-                <a:latin typeface="Arial"/>
-              </a:rPr>
-              <a:t>The Problem &amp; its Significance</a:t>
-            </a:r>
-            <a:endParaRPr b="0" lang="en-US" sz="4400" strike="noStrike" u="none">
-              <a:solidFill>
-                <a:srgbClr val="000000"/>
-              </a:solidFill>
-              <a:effectLst/>
-              <a:uFillTx/>
-              <a:latin typeface="Arial"/>
-            </a:endParaRPr>
-          </a:p>
-        </p:txBody>
-      </p:sp>
-      <p:sp>
-        <p:nvSpPr>
-          <p:cNvPr id="17" name="PlaceHolder 2"/>
-          <p:cNvSpPr>
-            <a:spLocks noGrp="1"/>
-          </p:cNvSpPr>
-          <p:nvPr>
-            <p:ph/>
-          </p:nvPr>
-        </p:nvSpPr>
-        <p:spPr>
-          <a:xfrm>
-            <a:off x="504000" y="1326600"/>
-            <a:ext cx="9071640" cy="3288240"/>
-          </a:xfrm>
-          <a:prstGeom prst="rect">
-            <a:avLst/>
-          </a:prstGeom>
-          <a:noFill/>
-          <a:ln w="0">
-            <a:noFill/>
-          </a:ln>
-        </p:spPr>
-        <p:txBody>
-          <a:bodyPr lIns="0" rIns="0" tIns="0" bIns="0" anchor="t">
-            <a:normAutofit/>
-          </a:bodyPr>
-          <a:p>
-            <a:pPr marL="432000" indent="-324000">
-              <a:spcBef>
-                <a:spcPts val="1417"/>
-              </a:spcBef>
-              <a:buClr>
-                <a:srgbClr val="000000"/>
-              </a:buClr>
-              <a:buSzPct val="45000"/>
-              <a:buFont typeface="Wingdings" charset="2"/>
-              <a:buChar char=""/>
-            </a:pPr>
+            <a:pPr algn="ctr"/>
             <a:r>
               <a:rPr b="0" lang="en-US" sz="3200" strike="noStrike" u="none">
                 <a:solidFill>
@@ -2359,7 +3924,7 @@
                 <a:uFillTx/>
                 <a:latin typeface="Arial"/>
               </a:rPr>
-              <a:t>RQ: How does MG use Christian culture to convey a pro-revolutionary message to readers?</a:t>
+              <a:t>The Idea</a:t>
             </a:r>
             <a:endParaRPr b="0" lang="en-US" sz="3200" strike="noStrike" u="none">
               <a:solidFill>
@@ -2442,7 +4007,7 @@
                 <a:uFillTx/>
                 <a:latin typeface="Arial"/>
               </a:rPr>
-              <a:t>Concepts &amp; Framework</a:t>
+              <a:t>The Problem &amp; its Significance</a:t>
             </a:r>
             <a:endParaRPr b="0" lang="en-US" sz="4400" strike="noStrike" u="none">
               <a:solidFill>
@@ -2480,7 +4045,7 @@
         </p:spPr>
         <p:txBody>
           <a:bodyPr lIns="0" rIns="0" tIns="0" bIns="0" anchor="t">
-            <a:normAutofit fontScale="85000" lnSpcReduction="9999"/>
+            <a:normAutofit/>
           </a:bodyPr>
           <a:p>
             <a:pPr marL="432000" indent="-324000">
@@ -2503,7 +4068,7 @@
                 <a:uFillTx/>
                 <a:latin typeface="Arial"/>
               </a:rPr>
-              <a:t>Transposition: method, reuse of literary element(s) in another narrative to impose consideration of the original’s significance in a new context</a:t>
+              <a:t>RQ: How does MG use Christian culture to convey a pro-revolutionary message?</a:t>
             </a:r>
             <a:endParaRPr b="0" lang="en-US" sz="3200" strike="noStrike" u="none">
               <a:solidFill>
@@ -2535,7 +4100,7 @@
                 <a:uFillTx/>
                 <a:latin typeface="Arial"/>
               </a:rPr>
-              <a:t>Post-Christianity: motive, a worldview that moves beyond Christian hegemony to pluralism</a:t>
+              <a:t>Past research had suggested ad-hoc use of Christianity</a:t>
             </a:r>
             <a:endParaRPr b="0" lang="en-US" sz="3200" strike="noStrike" u="none">
               <a:solidFill>
@@ -2567,39 +4132,7 @@
                 <a:uFillTx/>
                 <a:latin typeface="Arial"/>
               </a:rPr>
-              <a:t>Religious impulse: means, the human instinct to seek communion with something greater than the individual</a:t>
-            </a:r>
-            <a:endParaRPr b="0" lang="en-US" sz="3200" strike="noStrike" u="none">
-              <a:solidFill>
-                <a:srgbClr val="000000"/>
-              </a:solidFill>
-              <a:effectLst/>
-              <a:uFillTx/>
-              <a:latin typeface="Arial"/>
-            </a:endParaRPr>
-          </a:p>
-          <a:p>
-            <a:pPr marL="432000" indent="-324000">
-              <a:spcBef>
-                <a:spcPts val="1417"/>
-              </a:spcBef>
-              <a:buClr>
-                <a:srgbClr val="000000"/>
-              </a:buClr>
-              <a:buSzPct val="45000"/>
-              <a:buFont typeface="Wingdings" charset="2"/>
-              <a:buChar char=""/>
-            </a:pPr>
-            <a:r>
-              <a:rPr b="0" lang="en-US" sz="3200" strike="noStrike" u="none">
-                <a:solidFill>
-                  <a:srgbClr val="000000"/>
-                </a:solidFill>
-                <a:effectLst/>
-                <a:uFillTx/>
-                <a:latin typeface="Arial"/>
-              </a:rPr>
-              <a:t>MG’s argument for revolution</a:t>
+              <a:t>Demonstrating a systematic connection has scholarly &amp; cultural implications</a:t>
             </a:r>
             <a:endParaRPr b="0" lang="en-US" sz="3200" strike="noStrike" u="none">
               <a:solidFill>
@@ -2649,13 +4182,13 @@
             <a:spLocks noGrp="1"/>
           </p:cNvSpPr>
           <p:nvPr>
-            <p:ph type="subTitle"/>
+            <p:ph type="title"/>
           </p:nvPr>
         </p:nvSpPr>
         <p:spPr>
           <a:xfrm>
             <a:off x="504000" y="226080"/>
-            <a:ext cx="9071640" cy="4388400"/>
+            <a:ext cx="9071640" cy="946440"/>
           </a:xfrm>
           <a:prstGeom prst="rect">
             <a:avLst/>
@@ -2670,7 +4203,70 @@
             <a:spAutoFit/>
           </a:bodyPr>
           <a:p>
-            <a:pPr algn="ctr"/>
+            <a:pPr indent="0" algn="ctr">
+              <a:buNone/>
+            </a:pPr>
+            <a:r>
+              <a:rPr b="0" lang="en-US" sz="4400" strike="noStrike" u="none">
+                <a:solidFill>
+                  <a:srgbClr val="000000"/>
+                </a:solidFill>
+                <a:effectLst/>
+                <a:uFillTx/>
+                <a:latin typeface="Arial"/>
+              </a:rPr>
+              <a:t>Understanding MG’s Argument</a:t>
+            </a:r>
+            <a:endParaRPr b="0" lang="en-US" sz="4400" strike="noStrike" u="none">
+              <a:solidFill>
+                <a:srgbClr val="000000"/>
+              </a:solidFill>
+              <a:effectLst/>
+              <a:uFillTx/>
+              <a:latin typeface="Arial"/>
+            </a:endParaRPr>
+          </a:p>
+        </p:txBody>
+      </p:sp>
+      <p:sp>
+        <p:nvSpPr>
+          <p:cNvPr id="21" name="PlaceHolder 2"/>
+          <p:cNvSpPr>
+            <a:spLocks noGrp="1"/>
+          </p:cNvSpPr>
+          <p:nvPr>
+            <p:ph/>
+          </p:nvPr>
+        </p:nvSpPr>
+        <p:spPr>
+          <a:xfrm>
+            <a:off x="504000" y="1326600"/>
+            <a:ext cx="9071640" cy="3288240"/>
+          </a:xfrm>
+          <a:prstGeom prst="rect">
+            <a:avLst/>
+          </a:prstGeom>
+          <a:noFill/>
+          <a:ln w="0">
+            <a:noFill/>
+          </a:ln>
+        </p:spPr>
+        <p:txBody>
+          <a:bodyPr lIns="0" rIns="0" tIns="0" bIns="0" anchor="t">
+            <a:normAutofit fontScale="62500" lnSpcReduction="19999"/>
+          </a:bodyPr>
+          <a:p>
+            <a:pPr marL="432000" indent="-324000">
+              <a:spcBef>
+                <a:spcPts val="1417"/>
+              </a:spcBef>
+              <a:buClr>
+                <a:srgbClr val="000000"/>
+              </a:buClr>
+              <a:buSzPct val="45000"/>
+              <a:buFont typeface="Wingdings" charset="2"/>
+              <a:buChar char=""/>
+            </a:pPr>
             <a:r>
               <a:rPr b="0" lang="en-US" sz="3200" strike="noStrike" u="none">
                 <a:solidFill>
@@ -2680,9 +4276,265 @@
                 <a:uFillTx/>
                 <a:latin typeface="Arial"/>
               </a:rPr>
-              <a:t>The Starting Point</a:t>
+              <a:t>Transposition (mechanism)</a:t>
             </a:r>
             <a:endParaRPr b="0" lang="en-US" sz="3200" strike="noStrike" u="none">
+              <a:solidFill>
+                <a:srgbClr val="000000"/>
+              </a:solidFill>
+              <a:effectLst/>
+              <a:uFillTx/>
+              <a:latin typeface="Arial"/>
+            </a:endParaRPr>
+          </a:p>
+          <a:p>
+            <a:pPr lvl="1" marL="864000" indent="-324000">
+              <a:spcBef>
+                <a:spcPts val="1134"/>
+              </a:spcBef>
+              <a:buClr>
+                <a:srgbClr val="000000"/>
+              </a:buClr>
+              <a:buSzPct val="75000"/>
+              <a:buFont typeface="Symbol" charset="2"/>
+              <a:buChar char=""/>
+            </a:pPr>
+            <a:r>
+              <a:rPr b="0" lang="en-US" sz="2800" strike="noStrike" u="none">
+                <a:solidFill>
+                  <a:srgbClr val="000000"/>
+                </a:solidFill>
+                <a:effectLst/>
+                <a:uFillTx/>
+                <a:latin typeface="Arial"/>
+              </a:rPr>
+              <a:t>reuse of recognizable cultural elements implemented to impose juxtaposition of the original and derivative</a:t>
+            </a:r>
+            <a:endParaRPr b="0" lang="en-US" sz="2800" strike="noStrike" u="none">
+              <a:solidFill>
+                <a:srgbClr val="000000"/>
+              </a:solidFill>
+              <a:effectLst/>
+              <a:uFillTx/>
+              <a:latin typeface="Arial"/>
+            </a:endParaRPr>
+          </a:p>
+          <a:p>
+            <a:pPr lvl="2" marL="1296000" indent="-288000">
+              <a:spcBef>
+                <a:spcPts val="850"/>
+              </a:spcBef>
+              <a:buClr>
+                <a:srgbClr val="000000"/>
+              </a:buClr>
+              <a:buSzPct val="45000"/>
+              <a:buFont typeface="Wingdings" charset="2"/>
+              <a:buChar char=""/>
+            </a:pPr>
+            <a:r>
+              <a:rPr b="0" lang="en-US" sz="2400" strike="noStrike" u="none">
+                <a:solidFill>
+                  <a:srgbClr val="000000"/>
+                </a:solidFill>
+                <a:effectLst/>
+                <a:uFillTx/>
+                <a:latin typeface="Arial"/>
+              </a:rPr>
+              <a:t>Biblical elements in critique of contemporary Russia</a:t>
+            </a:r>
+            <a:endParaRPr b="0" lang="en-US" sz="2400" strike="noStrike" u="none">
+              <a:solidFill>
+                <a:srgbClr val="000000"/>
+              </a:solidFill>
+              <a:effectLst/>
+              <a:uFillTx/>
+              <a:latin typeface="Arial"/>
+            </a:endParaRPr>
+          </a:p>
+          <a:p>
+            <a:pPr marL="432000" indent="-324000">
+              <a:spcBef>
+                <a:spcPts val="1417"/>
+              </a:spcBef>
+              <a:buClr>
+                <a:srgbClr val="000000"/>
+              </a:buClr>
+              <a:buSzPct val="45000"/>
+              <a:buFont typeface="Wingdings" charset="2"/>
+              <a:buChar char=""/>
+            </a:pPr>
+            <a:r>
+              <a:rPr b="0" lang="en-US" sz="3200" strike="noStrike" u="none">
+                <a:solidFill>
+                  <a:srgbClr val="000000"/>
+                </a:solidFill>
+                <a:effectLst/>
+                <a:uFillTx/>
+                <a:latin typeface="Arial"/>
+              </a:rPr>
+              <a:t>Post-Christianity (motive)</a:t>
+            </a:r>
+            <a:endParaRPr b="0" lang="en-US" sz="3200" strike="noStrike" u="none">
+              <a:solidFill>
+                <a:srgbClr val="000000"/>
+              </a:solidFill>
+              <a:effectLst/>
+              <a:uFillTx/>
+              <a:latin typeface="Arial"/>
+            </a:endParaRPr>
+          </a:p>
+          <a:p>
+            <a:pPr lvl="1" marL="864000" indent="-324000">
+              <a:spcBef>
+                <a:spcPts val="1134"/>
+              </a:spcBef>
+              <a:buClr>
+                <a:srgbClr val="000000"/>
+              </a:buClr>
+              <a:buSzPct val="75000"/>
+              <a:buFont typeface="Symbol" charset="2"/>
+              <a:buChar char=""/>
+            </a:pPr>
+            <a:r>
+              <a:rPr b="0" lang="en-US" sz="2800" strike="noStrike" u="none">
+                <a:solidFill>
+                  <a:srgbClr val="000000"/>
+                </a:solidFill>
+                <a:effectLst/>
+                <a:uFillTx/>
+                <a:latin typeface="Arial"/>
+              </a:rPr>
+              <a:t>Worldview of the transition away from Christian hegemony</a:t>
+            </a:r>
+            <a:endParaRPr b="0" lang="en-US" sz="2800" strike="noStrike" u="none">
+              <a:solidFill>
+                <a:srgbClr val="000000"/>
+              </a:solidFill>
+              <a:effectLst/>
+              <a:uFillTx/>
+              <a:latin typeface="Arial"/>
+            </a:endParaRPr>
+          </a:p>
+          <a:p>
+            <a:pPr lvl="2" marL="1296000" indent="-288000">
+              <a:spcBef>
+                <a:spcPts val="850"/>
+              </a:spcBef>
+              <a:buClr>
+                <a:srgbClr val="000000"/>
+              </a:buClr>
+              <a:buSzPct val="45000"/>
+              <a:buFont typeface="Wingdings" charset="2"/>
+              <a:buChar char=""/>
+            </a:pPr>
+            <a:r>
+              <a:rPr b="0" lang="en-US" sz="2400" strike="noStrike" u="none">
+                <a:solidFill>
+                  <a:srgbClr val="000000"/>
+                </a:solidFill>
+                <a:effectLst/>
+                <a:uFillTx/>
+                <a:latin typeface="Arial"/>
+              </a:rPr>
+              <a:t>Spiritual socialism replaces everyday and existential significance of Christianity</a:t>
+            </a:r>
+            <a:endParaRPr b="0" lang="en-US" sz="2400" strike="noStrike" u="none">
+              <a:solidFill>
+                <a:srgbClr val="000000"/>
+              </a:solidFill>
+              <a:effectLst/>
+              <a:uFillTx/>
+              <a:latin typeface="Arial"/>
+            </a:endParaRPr>
+          </a:p>
+          <a:p>
+            <a:pPr marL="432000" indent="-324000">
+              <a:spcBef>
+                <a:spcPts val="1417"/>
+              </a:spcBef>
+              <a:buClr>
+                <a:srgbClr val="000000"/>
+              </a:buClr>
+              <a:buSzPct val="45000"/>
+              <a:buFont typeface="Wingdings" charset="2"/>
+              <a:buChar char=""/>
+            </a:pPr>
+            <a:r>
+              <a:rPr b="0" lang="en-US" sz="3200" strike="noStrike" u="none">
+                <a:solidFill>
+                  <a:srgbClr val="000000"/>
+                </a:solidFill>
+                <a:effectLst/>
+                <a:uFillTx/>
+                <a:latin typeface="Arial"/>
+              </a:rPr>
+              <a:t>Religious impulse (means)</a:t>
+            </a:r>
+            <a:endParaRPr b="0" lang="en-US" sz="3200" strike="noStrike" u="none">
+              <a:solidFill>
+                <a:srgbClr val="000000"/>
+              </a:solidFill>
+              <a:effectLst/>
+              <a:uFillTx/>
+              <a:latin typeface="Arial"/>
+            </a:endParaRPr>
+          </a:p>
+          <a:p>
+            <a:pPr lvl="1" marL="864000" indent="-324000">
+              <a:spcBef>
+                <a:spcPts val="1134"/>
+              </a:spcBef>
+              <a:buClr>
+                <a:srgbClr val="000000"/>
+              </a:buClr>
+              <a:buSzPct val="75000"/>
+              <a:buFont typeface="Symbol" charset="2"/>
+              <a:buChar char=""/>
+            </a:pPr>
+            <a:r>
+              <a:rPr b="0" lang="en-US" sz="2800" strike="noStrike" u="none">
+                <a:solidFill>
+                  <a:srgbClr val="000000"/>
+                </a:solidFill>
+                <a:effectLst/>
+                <a:uFillTx/>
+                <a:latin typeface="Arial"/>
+              </a:rPr>
+              <a:t>the human instinct to seek communion with something greater than the individual</a:t>
+            </a:r>
+            <a:endParaRPr b="0" lang="en-US" sz="2800" strike="noStrike" u="none">
+              <a:solidFill>
+                <a:srgbClr val="000000"/>
+              </a:solidFill>
+              <a:effectLst/>
+              <a:uFillTx/>
+              <a:latin typeface="Arial"/>
+            </a:endParaRPr>
+          </a:p>
+          <a:p>
+            <a:pPr lvl="2" marL="1296000" indent="-288000">
+              <a:spcBef>
+                <a:spcPts val="850"/>
+              </a:spcBef>
+              <a:buClr>
+                <a:srgbClr val="000000"/>
+              </a:buClr>
+              <a:buSzPct val="45000"/>
+              <a:buFont typeface="Wingdings" charset="2"/>
+              <a:buChar char=""/>
+            </a:pPr>
+            <a:r>
+              <a:rPr b="0" lang="en-US" sz="2400" strike="noStrike" u="none">
+                <a:solidFill>
+                  <a:srgbClr val="000000"/>
+                </a:solidFill>
+                <a:effectLst/>
+                <a:uFillTx/>
+                <a:latin typeface="Arial"/>
+              </a:rPr>
+              <a:t>Class and human solidarity</a:t>
+            </a:r>
+            <a:endParaRPr b="0" lang="en-US" sz="2400" strike="noStrike" u="none">
               <a:solidFill>
                 <a:srgbClr val="000000"/>
               </a:solidFill>
@@ -2725,18 +4577,18 @@
       </p:grpSpPr>
       <p:sp>
         <p:nvSpPr>
-          <p:cNvPr id="21" name="PlaceHolder 1"/>
+          <p:cNvPr id="22" name="PlaceHolder 1"/>
           <p:cNvSpPr>
             <a:spLocks noGrp="1"/>
           </p:cNvSpPr>
           <p:nvPr>
-            <p:ph type="title"/>
+            <p:ph type="subTitle"/>
           </p:nvPr>
         </p:nvSpPr>
         <p:spPr>
           <a:xfrm>
             <a:off x="504000" y="226080"/>
-            <a:ext cx="9071640" cy="946440"/>
+            <a:ext cx="9071640" cy="4388400"/>
           </a:xfrm>
           <a:prstGeom prst="rect">
             <a:avLst/>
@@ -2751,65 +4603,18 @@
             <a:spAutoFit/>
           </a:bodyPr>
           <a:p>
-            <a:pPr indent="0" algn="ctr">
-              <a:buNone/>
-            </a:pPr>
-            <a:r>
-              <a:rPr b="0" lang="en-US" sz="4400" strike="noStrike" u="none">
-                <a:solidFill>
-                  <a:srgbClr val="000000"/>
-                </a:solidFill>
-                <a:effectLst/>
-                <a:uFillTx/>
-                <a:latin typeface="Arial"/>
-              </a:rPr>
-              <a:t>Scholarly Conception of MG</a:t>
-            </a:r>
-            <a:endParaRPr b="0" lang="en-US" sz="4400" strike="noStrike" u="none">
-              <a:solidFill>
-                <a:srgbClr val="000000"/>
-              </a:solidFill>
-              <a:effectLst/>
-              <a:uFillTx/>
-              <a:latin typeface="Arial"/>
-            </a:endParaRPr>
-          </a:p>
-        </p:txBody>
-      </p:sp>
-      <p:sp>
-        <p:nvSpPr>
-          <p:cNvPr id="22" name="PlaceHolder 2"/>
-          <p:cNvSpPr>
-            <a:spLocks noGrp="1"/>
-          </p:cNvSpPr>
-          <p:nvPr>
-            <p:ph/>
-          </p:nvPr>
-        </p:nvSpPr>
-        <p:spPr>
-          <a:xfrm>
-            <a:off x="504000" y="1326600"/>
-            <a:ext cx="9071640" cy="3288240"/>
-          </a:xfrm>
-          <a:prstGeom prst="rect">
-            <a:avLst/>
-          </a:prstGeom>
-          <a:noFill/>
-          <a:ln w="0">
-            <a:noFill/>
-          </a:ln>
-        </p:spPr>
-        <p:txBody>
-          <a:bodyPr lIns="0" rIns="0" tIns="0" bIns="0" anchor="t">
-            <a:normAutofit/>
-          </a:bodyPr>
-          <a:p>
-            <a:pPr indent="0">
-              <a:spcBef>
-                <a:spcPts val="1417"/>
-              </a:spcBef>
-              <a:buNone/>
-            </a:pPr>
+            <a:pPr algn="ctr"/>
+            <a:r>
+              <a:rPr b="0" lang="en-US" sz="3200" strike="noStrike" u="none">
+                <a:solidFill>
+                  <a:srgbClr val="000000"/>
+                </a:solidFill>
+                <a:effectLst/>
+                <a:uFillTx/>
+                <a:latin typeface="Arial"/>
+              </a:rPr>
+              <a:t>The Starting Point</a:t>
+            </a:r>
             <a:endParaRPr b="0" lang="en-US" sz="3200" strike="noStrike" u="none">
               <a:solidFill>
                 <a:srgbClr val="000000"/>
@@ -2858,13 +4663,13 @@
             <a:spLocks noGrp="1"/>
           </p:cNvSpPr>
           <p:nvPr>
-            <p:ph type="subTitle"/>
+            <p:ph type="title"/>
           </p:nvPr>
         </p:nvSpPr>
         <p:spPr>
           <a:xfrm>
             <a:off x="504000" y="226080"/>
-            <a:ext cx="9071640" cy="4388400"/>
+            <a:ext cx="9071640" cy="946440"/>
           </a:xfrm>
           <a:prstGeom prst="rect">
             <a:avLst/>
@@ -2879,7 +4684,70 @@
             <a:spAutoFit/>
           </a:bodyPr>
           <a:p>
-            <a:pPr algn="ctr"/>
+            <a:pPr indent="0" algn="ctr">
+              <a:buNone/>
+            </a:pPr>
+            <a:r>
+              <a:rPr b="0" lang="en-US" sz="4400" strike="noStrike" u="none">
+                <a:solidFill>
+                  <a:srgbClr val="000000"/>
+                </a:solidFill>
+                <a:effectLst/>
+                <a:uFillTx/>
+                <a:latin typeface="Arial"/>
+              </a:rPr>
+              <a:t>Popular Conception of MG</a:t>
+            </a:r>
+            <a:endParaRPr b="0" lang="en-US" sz="4400" strike="noStrike" u="none">
+              <a:solidFill>
+                <a:srgbClr val="000000"/>
+              </a:solidFill>
+              <a:effectLst/>
+              <a:uFillTx/>
+              <a:latin typeface="Arial"/>
+            </a:endParaRPr>
+          </a:p>
+        </p:txBody>
+      </p:sp>
+      <p:sp>
+        <p:nvSpPr>
+          <p:cNvPr id="24" name="PlaceHolder 2"/>
+          <p:cNvSpPr>
+            <a:spLocks noGrp="1"/>
+          </p:cNvSpPr>
+          <p:nvPr>
+            <p:ph/>
+          </p:nvPr>
+        </p:nvSpPr>
+        <p:spPr>
+          <a:xfrm>
+            <a:off x="504000" y="1326600"/>
+            <a:ext cx="9071640" cy="3288240"/>
+          </a:xfrm>
+          <a:prstGeom prst="rect">
+            <a:avLst/>
+          </a:prstGeom>
+          <a:noFill/>
+          <a:ln w="0">
+            <a:noFill/>
+          </a:ln>
+        </p:spPr>
+        <p:txBody>
+          <a:bodyPr lIns="0" rIns="0" tIns="0" bIns="0" anchor="t">
+            <a:normAutofit/>
+          </a:bodyPr>
+          <a:p>
+            <a:pPr marL="432000" indent="-324000">
+              <a:spcBef>
+                <a:spcPts val="1417"/>
+              </a:spcBef>
+              <a:buClr>
+                <a:srgbClr val="000000"/>
+              </a:buClr>
+              <a:buSzPct val="45000"/>
+              <a:buFont typeface="Wingdings" charset="2"/>
+              <a:buChar char=""/>
+            </a:pPr>
             <a:r>
               <a:rPr b="0" lang="en-US" sz="3200" strike="noStrike" u="none">
                 <a:solidFill>
@@ -2889,7 +4757,103 @@
                 <a:uFillTx/>
                 <a:latin typeface="Arial"/>
               </a:rPr>
-              <a:t>The Results</a:t>
+              <a:t>b. 1868, d. 1936, active 1892-death</a:t>
+            </a:r>
+            <a:endParaRPr b="0" lang="en-US" sz="3200" strike="noStrike" u="none">
+              <a:solidFill>
+                <a:srgbClr val="000000"/>
+              </a:solidFill>
+              <a:effectLst/>
+              <a:uFillTx/>
+              <a:latin typeface="Arial"/>
+            </a:endParaRPr>
+          </a:p>
+          <a:p>
+            <a:pPr marL="432000" indent="-324000">
+              <a:spcBef>
+                <a:spcPts val="1417"/>
+              </a:spcBef>
+              <a:buClr>
+                <a:srgbClr val="000000"/>
+              </a:buClr>
+              <a:buSzPct val="45000"/>
+              <a:buFont typeface="Wingdings" charset="2"/>
+              <a:buChar char=""/>
+            </a:pPr>
+            <a:r>
+              <a:rPr b="0" lang="en-US" sz="3200" strike="noStrike" u="none">
+                <a:solidFill>
+                  <a:srgbClr val="000000"/>
+                </a:solidFill>
+                <a:effectLst/>
+                <a:uFillTx/>
+                <a:latin typeface="Arial"/>
+              </a:rPr>
+              <a:t>Writer known for prose and drama</a:t>
+            </a:r>
+            <a:endParaRPr b="0" lang="en-US" sz="3200" strike="noStrike" u="none">
+              <a:solidFill>
+                <a:srgbClr val="000000"/>
+              </a:solidFill>
+              <a:effectLst/>
+              <a:uFillTx/>
+              <a:latin typeface="Arial"/>
+            </a:endParaRPr>
+          </a:p>
+          <a:p>
+            <a:pPr marL="432000" indent="-324000">
+              <a:spcBef>
+                <a:spcPts val="1417"/>
+              </a:spcBef>
+              <a:buClr>
+                <a:srgbClr val="000000"/>
+              </a:buClr>
+              <a:buSzPct val="45000"/>
+              <a:buFont typeface="Wingdings" charset="2"/>
+              <a:buChar char=""/>
+            </a:pPr>
+            <a:r>
+              <a:rPr b="0" lang="en-US" sz="3200" strike="noStrike" u="none">
+                <a:solidFill>
+                  <a:srgbClr val="000000"/>
+                </a:solidFill>
+                <a:effectLst/>
+                <a:uFillTx/>
+                <a:latin typeface="Arial"/>
+              </a:rPr>
+              <a:t>Helped bankroll Bolshevik revolution, became mythical figurehead in Soviet Union</a:t>
+            </a:r>
+            <a:endParaRPr b="0" lang="en-US" sz="3200" strike="noStrike" u="none">
+              <a:solidFill>
+                <a:srgbClr val="000000"/>
+              </a:solidFill>
+              <a:effectLst/>
+              <a:uFillTx/>
+              <a:latin typeface="Arial"/>
+            </a:endParaRPr>
+          </a:p>
+          <a:p>
+            <a:pPr marL="432000" indent="-324000">
+              <a:spcBef>
+                <a:spcPts val="1417"/>
+              </a:spcBef>
+              <a:buClr>
+                <a:srgbClr val="000000"/>
+              </a:buClr>
+              <a:buSzPct val="45000"/>
+              <a:buFont typeface="Wingdings" charset="2"/>
+              <a:buChar char=""/>
+            </a:pPr>
+            <a:r>
+              <a:rPr b="0" lang="en-US" sz="3200" strike="noStrike" u="none">
+                <a:solidFill>
+                  <a:srgbClr val="000000"/>
+                </a:solidFill>
+                <a:effectLst/>
+                <a:uFillTx/>
+                <a:latin typeface="Arial"/>
+              </a:rPr>
+              <a:t>Identity (as socialist firebrand) heavily intertwined with Soviet a(nti-)theist propaganda</a:t>
             </a:r>
             <a:endParaRPr b="0" lang="en-US" sz="3200" strike="noStrike" u="none">
               <a:solidFill>

</xml_diff>